<commit_message>
Build Antarctica checkout preview and expedition inventory foundation
</commit_message>
<xml_diff>
--- a/outputs/manual-20260930-parka/presentations/parka-pricing-deliverables/antarctica-parka-pricing.pptx
+++ b/outputs/manual-20260930-parka/presentations/parka-pricing-deliverables/antarctica-parka-pricing.pptx
@@ -2,13 +2,13 @@
 <file path=ppt/presentation.xml><?xml version="1.0" encoding="utf-8"?>
 <p:presentation xmlns:p="http://schemas.openxmlformats.org/presentationml/2006/main">
   <p:sldMasterIdLst>
-    <p:sldMasterId xmlns:r="http://schemas.openxmlformats.org/officeDocument/2006/relationships" id="2147483648" r:id="Ra91280ed2c7f4cbc"/>
+    <p:sldMasterId xmlns:r="http://schemas.openxmlformats.org/officeDocument/2006/relationships" id="2147483648" r:id="R3e55fb6b96084bec"/>
   </p:sldMasterIdLst>
   <p:notesMasterIdLst>
-    <p:notesMasterId xmlns:r="http://schemas.openxmlformats.org/officeDocument/2006/relationships" r:id="Re20a3ef4e5ef44a2"/>
+    <p:notesMasterId xmlns:r="http://schemas.openxmlformats.org/officeDocument/2006/relationships" r:id="R3cfd678f66194484"/>
   </p:notesMasterIdLst>
   <p:sldIdLst>
-    <p:sldId xmlns:r="http://schemas.openxmlformats.org/officeDocument/2006/relationships" id="256" r:id="R1d9e7d6f57b84a56"/>
+    <p:sldId xmlns:r="http://schemas.openxmlformats.org/officeDocument/2006/relationships" id="256" r:id="Rc4b2bcb98bd34a85"/>
   </p:sldIdLst>
   <p:sldSz cx="15240000" cy="8572500"/>
   <p:notesSz cx="6858000" cy="9144000"/>
@@ -555,7 +555,7 @@
   </p:cSld>
   <p:clrMap bg1="lt1" tx1="dk1" bg2="lt2" tx2="dk2" accent1="accent1" accent2="accent2" accent3="accent3" accent4="accent4" accent5="accent5" accent6="accent6" hlink="hlink" folHlink="folHlink"/>
   <p:sldLayoutIdLst>
-    <p:sldLayoutId xmlns:r="http://schemas.openxmlformats.org/officeDocument/2006/relationships" id="2147483649" r:id="Rfff1916fce134269"/>
+    <p:sldLayoutId xmlns:r="http://schemas.openxmlformats.org/officeDocument/2006/relationships" id="2147483649" r:id="R2a0e0ce299ce448d"/>
   </p:sldLayoutIdLst>
   <p:txStyles>
     <p:titleStyle>
@@ -865,7 +865,7 @@
           <p:nvPr/>
         </p:nvPicPr>
         <p:blipFill>
-          <a:blip xmlns:r="http://schemas.openxmlformats.org/officeDocument/2006/relationships" xmlns:a="http://schemas.openxmlformats.org/drawingml/2006/main" r:embed="R0444900d97a54579"/>
+          <a:blip xmlns:r="http://schemas.openxmlformats.org/officeDocument/2006/relationships" xmlns:a="http://schemas.openxmlformats.org/drawingml/2006/main" r:embed="R7396f9b952854ad7"/>
           <a:stretch xmlns:a="http://schemas.openxmlformats.org/drawingml/2006/main"/>
         </p:blipFill>
         <p:spPr>
@@ -933,6 +933,7 @@
           <a:lstStyle xmlns:a="http://schemas.openxmlformats.org/drawingml/2006/main"/>
           <a:p xmlns:a="http://schemas.openxmlformats.org/drawingml/2006/main">
             <a:pPr algn="l">
+              <a:buNone/>
               <a:defRPr sz="1050" b="0">
                 <a:solidFill>
                   <a:srgbClr val="56686A"/>
@@ -984,6 +985,7 @@
           <a:lstStyle xmlns:a="http://schemas.openxmlformats.org/drawingml/2006/main"/>
           <a:p xmlns:a="http://schemas.openxmlformats.org/drawingml/2006/main">
             <a:pPr algn="r">
+              <a:buNone/>
               <a:defRPr sz="900" b="0">
                 <a:solidFill>
                   <a:srgbClr val="56686A"/>
@@ -1035,6 +1037,7 @@
           <a:lstStyle xmlns:a="http://schemas.openxmlformats.org/drawingml/2006/main"/>
           <a:p xmlns:a="http://schemas.openxmlformats.org/drawingml/2006/main">
             <a:pPr algn="l">
+              <a:buNone/>
               <a:defRPr sz="4125" b="0">
                 <a:solidFill>
                   <a:srgbClr val="102E38"/>
@@ -1086,6 +1089,7 @@
           <a:lstStyle xmlns:a="http://schemas.openxmlformats.org/drawingml/2006/main"/>
           <a:p xmlns:a="http://schemas.openxmlformats.org/drawingml/2006/main">
             <a:pPr algn="l">
+              <a:buNone/>
               <a:defRPr sz="1575" b="0">
                 <a:solidFill>
                   <a:srgbClr val="56686A"/>
@@ -1164,6 +1168,7 @@
           <a:lstStyle xmlns:a="http://schemas.openxmlformats.org/drawingml/2006/main"/>
           <a:p xmlns:a="http://schemas.openxmlformats.org/drawingml/2006/main">
             <a:pPr algn="l">
+              <a:buNone/>
               <a:defRPr sz="2925" b="0">
                 <a:solidFill>
                   <a:srgbClr val="F3EFDF"/>
@@ -1215,6 +1220,7 @@
           <a:lstStyle xmlns:a="http://schemas.openxmlformats.org/drawingml/2006/main"/>
           <a:p xmlns:a="http://schemas.openxmlformats.org/drawingml/2006/main">
             <a:pPr algn="l">
+              <a:buNone/>
               <a:defRPr sz="975" b="0">
                 <a:solidFill>
                   <a:srgbClr val="D5B477"/>
@@ -1247,10 +1253,10 @@
           <p:nvPr/>
         </p:nvPicPr>
         <p:blipFill>
-          <a:blip xmlns:r="http://schemas.openxmlformats.org/officeDocument/2006/relationships" xmlns:a="http://schemas.openxmlformats.org/drawingml/2006/main" r:embed="R78d704c231904ab9">
+          <a:blip xmlns:r="http://schemas.openxmlformats.org/officeDocument/2006/relationships" xmlns:a="http://schemas.openxmlformats.org/drawingml/2006/main" r:embed="R7396f9b952854ad7">
             <a:extLst>
               <a:ext uri="{96DAC541-7B7A-43D3-8B79-37D633B846F1}">
-                <asvg:svgBlip xmlns:asvg="http://schemas.microsoft.com/office/drawing/2016/SVG/main" r:embed="R7da2ff79d6734774"/>
+                <asvg:svgBlip xmlns:asvg="http://schemas.microsoft.com/office/drawing/2016/SVG/main" r:embed="R3e9bbea868f14327"/>
               </a:ext>
             </a:extLst>
           </a:blip>
@@ -1275,10 +1281,10 @@
           <p:nvPr/>
         </p:nvPicPr>
         <p:blipFill>
-          <a:blip xmlns:r="http://schemas.openxmlformats.org/officeDocument/2006/relationships" xmlns:a="http://schemas.openxmlformats.org/drawingml/2006/main" r:embed="Rf0266f037dc142c7">
+          <a:blip xmlns:r="http://schemas.openxmlformats.org/officeDocument/2006/relationships" xmlns:a="http://schemas.openxmlformats.org/drawingml/2006/main" r:embed="R320cc41c90d146b7">
             <a:extLst>
               <a:ext uri="{96DAC541-7B7A-43D3-8B79-37D633B846F1}">
-                <asvg:svgBlip xmlns:asvg="http://schemas.microsoft.com/office/drawing/2016/SVG/main" r:embed="R40362fd3a3364c76"/>
+                <asvg:svgBlip xmlns:asvg="http://schemas.microsoft.com/office/drawing/2016/SVG/main" r:embed="R8a6d3b7d005f4ae7"/>
               </a:ext>
             </a:extLst>
           </a:blip>
@@ -1322,6 +1328,7 @@
           <a:lstStyle xmlns:a="http://schemas.openxmlformats.org/drawingml/2006/main"/>
           <a:p xmlns:a="http://schemas.openxmlformats.org/drawingml/2006/main">
             <a:pPr algn="ctr">
+              <a:buNone/>
               <a:defRPr sz="900" b="0">
                 <a:solidFill>
                   <a:srgbClr val="F3EFDF"/>
@@ -1373,6 +1380,7 @@
           <a:lstStyle xmlns:a="http://schemas.openxmlformats.org/drawingml/2006/main"/>
           <a:p xmlns:a="http://schemas.openxmlformats.org/drawingml/2006/main">
             <a:pPr algn="ctr">
+              <a:buNone/>
               <a:defRPr sz="900" b="0">
                 <a:solidFill>
                   <a:srgbClr val="F3EFDF"/>
@@ -1424,6 +1432,7 @@
           <a:lstStyle xmlns:a="http://schemas.openxmlformats.org/drawingml/2006/main"/>
           <a:p xmlns:a="http://schemas.openxmlformats.org/drawingml/2006/main">
             <a:pPr algn="l">
+              <a:buNone/>
               <a:defRPr sz="1125" b="0">
                 <a:solidFill>
                   <a:srgbClr val="C6D4CE"/>
@@ -1475,6 +1484,7 @@
           <a:lstStyle xmlns:a="http://schemas.openxmlformats.org/drawingml/2006/main"/>
           <a:p xmlns:a="http://schemas.openxmlformats.org/drawingml/2006/main">
             <a:pPr algn="l">
+              <a:buNone/>
               <a:defRPr sz="900" b="0">
                 <a:solidFill>
                   <a:srgbClr val="56686A"/>
@@ -1514,7 +1524,7 @@
         </p:nvSpPr>
         <p:spPr>
           <a:xfrm xmlns:a="http://schemas.openxmlformats.org/drawingml/2006/main">
-            <a:off x="10668000" y="2457450"/>
+            <a:off x="11239500" y="2457450"/>
             <a:ext cx="685800" cy="266700"/>
           </a:xfrm>
           <a:prstGeom xmlns:a="http://schemas.openxmlformats.org/drawingml/2006/main" prst="rect">
@@ -1526,6 +1536,7 @@
           <a:lstStyle xmlns:a="http://schemas.openxmlformats.org/drawingml/2006/main"/>
           <a:p xmlns:a="http://schemas.openxmlformats.org/drawingml/2006/main">
             <a:pPr algn="ctr">
+              <a:buNone/>
               <a:defRPr sz="900" b="0">
                 <a:solidFill>
                   <a:srgbClr val="56686A"/>
@@ -1565,8 +1576,8 @@
         </p:nvSpPr>
         <p:spPr>
           <a:xfrm xmlns:a="http://schemas.openxmlformats.org/drawingml/2006/main">
-            <a:off x="11715750" y="2457450"/>
-            <a:ext cx="1219200" cy="266700"/>
+            <a:off x="12287250" y="2457450"/>
+            <a:ext cx="2371725" cy="266700"/>
           </a:xfrm>
           <a:prstGeom xmlns:a="http://schemas.openxmlformats.org/drawingml/2006/main" prst="rect">
             <a:avLst/>
@@ -1577,6 +1588,7 @@
           <a:lstStyle xmlns:a="http://schemas.openxmlformats.org/drawingml/2006/main"/>
           <a:p xmlns:a="http://schemas.openxmlformats.org/drawingml/2006/main">
             <a:pPr algn="r">
+              <a:buNone/>
               <a:defRPr sz="900" b="0">
                 <a:solidFill>
                   <a:srgbClr val="56686A"/>
@@ -1595,40 +1607,68 @@
                 <a:ea typeface="Courier New"/>
                 <a:cs typeface="Courier New"/>
               </a:rPr>
-              <a:t>PRICE EACH</a:t>
-            </a:r>
-          </a:p>
-        </p:txBody>
-      </p:sp>
-      <p:sp>
-        <p:nvSpPr>
-          <p:cNvPr id="18" name="table-total">
-            <a:extLst xmlns:a="http://schemas.openxmlformats.org/drawingml/2006/main">
-              <a:ext uri="{FF2B5EF4-FFF2-40B4-BE49-F238E27FC236}">
-                <a16:creationId xmlns:a16="http://schemas.microsoft.com/office/drawing/2014/main" id="{53607DF6-324D-4A0C-A026-252E057E9357}"/>
-              </a:ext>
-            </a:extLst>
-          </p:cNvPr>
-          <p:cNvSpPr>
-            <a:spLocks xmlns:a="http://schemas.openxmlformats.org/drawingml/2006/main" noGrp="1"/>
-          </p:cNvSpPr>
-          <p:nvPr/>
-        </p:nvSpPr>
-        <p:spPr>
-          <a:xfrm xmlns:a="http://schemas.openxmlformats.org/drawingml/2006/main">
-            <a:off x="13335000" y="2457450"/>
-            <a:ext cx="1323975" cy="266700"/>
-          </a:xfrm>
-          <a:prstGeom xmlns:a="http://schemas.openxmlformats.org/drawingml/2006/main" prst="rect">
-            <a:avLst/>
-          </a:prstGeom>
-        </p:spPr>
-        <p:txBody>
-          <a:bodyPr xmlns:a="http://schemas.openxmlformats.org/drawingml/2006/main" wrap="none" lIns="0" tIns="0" rIns="0" bIns="0" anchor="ctr"/>
-          <a:lstStyle xmlns:a="http://schemas.openxmlformats.org/drawingml/2006/main"/>
-          <a:p xmlns:a="http://schemas.openxmlformats.org/drawingml/2006/main">
-            <a:pPr algn="r">
-              <a:defRPr sz="900" b="0">
+              <a:t>PRICE PER PLACEMENT</a:t>
+            </a:r>
+          </a:p>
+        </p:txBody>
+      </p:sp>
+      <p:sp>
+        <p:nvSpPr>
+          <p:cNvPr id="19" name="row-rule-0">
+            <a:extLst xmlns:a="http://schemas.openxmlformats.org/drawingml/2006/main">
+              <a:ext uri="{FF2B5EF4-FFF2-40B4-BE49-F238E27FC236}">
+                <a16:creationId xmlns:a16="http://schemas.microsoft.com/office/drawing/2014/main" id="{6CEA316E-96A7-492D-91D5-8535B7F82373}"/>
+              </a:ext>
+            </a:extLst>
+          </p:cNvPr>
+          <p:cNvSpPr>
+            <a:spLocks xmlns:a="http://schemas.openxmlformats.org/drawingml/2006/main" noGrp="1"/>
+          </p:cNvSpPr>
+          <p:nvPr/>
+        </p:nvSpPr>
+        <p:spPr>
+          <a:xfrm xmlns:a="http://schemas.openxmlformats.org/drawingml/2006/main">
+            <a:off x="7477125" y="2828925"/>
+            <a:ext cx="7181850" cy="9525"/>
+          </a:xfrm>
+          <a:prstGeom xmlns:a="http://schemas.openxmlformats.org/drawingml/2006/main" prst="rect">
+            <a:avLst/>
+          </a:prstGeom>
+          <a:solidFill xmlns:a="http://schemas.openxmlformats.org/drawingml/2006/main">
+            <a:srgbClr val="BCAD86"/>
+          </a:solidFill>
+        </p:spPr>
+      </p:sp>
+      <p:sp>
+        <p:nvSpPr>
+          <p:cNvPr id="20" name="placement-number-0">
+            <a:extLst xmlns:a="http://schemas.openxmlformats.org/drawingml/2006/main">
+              <a:ext uri="{FF2B5EF4-FFF2-40B4-BE49-F238E27FC236}">
+                <a16:creationId xmlns:a16="http://schemas.microsoft.com/office/drawing/2014/main" id="{F0CDCDA2-FD2C-4FDF-B88D-57F89C74CD06}"/>
+              </a:ext>
+            </a:extLst>
+          </p:cNvPr>
+          <p:cNvSpPr>
+            <a:spLocks xmlns:a="http://schemas.openxmlformats.org/drawingml/2006/main" noGrp="1"/>
+          </p:cNvSpPr>
+          <p:nvPr/>
+        </p:nvSpPr>
+        <p:spPr>
+          <a:xfrm xmlns:a="http://schemas.openxmlformats.org/drawingml/2006/main">
+            <a:off x="7496175" y="2952750"/>
+            <a:ext cx="266700" cy="285750"/>
+          </a:xfrm>
+          <a:prstGeom xmlns:a="http://schemas.openxmlformats.org/drawingml/2006/main" prst="rect">
+            <a:avLst/>
+          </a:prstGeom>
+        </p:spPr>
+        <p:txBody>
+          <a:bodyPr xmlns:a="http://schemas.openxmlformats.org/drawingml/2006/main" wrap="none" lIns="0" tIns="0" rIns="0" bIns="0" anchor="ctr"/>
+          <a:lstStyle xmlns:a="http://schemas.openxmlformats.org/drawingml/2006/main"/>
+          <a:p xmlns:a="http://schemas.openxmlformats.org/drawingml/2006/main">
+            <a:pPr algn="l">
+              <a:buNone/>
+              <a:defRPr sz="1125" b="0">
                 <a:solidFill>
                   <a:srgbClr val="56686A"/>
                 </a:solidFill>
@@ -1638,7 +1678,7 @@
               </a:defRPr>
             </a:pPr>
             <a:r>
-              <a:rPr sz="900" b="0">
+              <a:rPr sz="1125" b="0">
                 <a:solidFill>
                   <a:srgbClr val="56686A"/>
                 </a:solidFill>
@@ -1646,28 +1686,184 @@
                 <a:ea typeface="Courier New"/>
                 <a:cs typeface="Courier New"/>
               </a:rPr>
-              <a:t>REVENUE</a:t>
-            </a:r>
-          </a:p>
-        </p:txBody>
-      </p:sp>
-      <p:sp>
-        <p:nvSpPr>
-          <p:cNvPr id="19" name="row-rule-0">
-            <a:extLst xmlns:a="http://schemas.openxmlformats.org/drawingml/2006/main">
-              <a:ext uri="{FF2B5EF4-FFF2-40B4-BE49-F238E27FC236}">
-                <a16:creationId xmlns:a16="http://schemas.microsoft.com/office/drawing/2014/main" id="{6CEA316E-96A7-492D-91D5-8535B7F82373}"/>
-              </a:ext>
-            </a:extLst>
-          </p:cNvPr>
-          <p:cNvSpPr>
-            <a:spLocks xmlns:a="http://schemas.openxmlformats.org/drawingml/2006/main" noGrp="1"/>
-          </p:cNvSpPr>
-          <p:nvPr/>
-        </p:nvSpPr>
-        <p:spPr>
-          <a:xfrm xmlns:a="http://schemas.openxmlformats.org/drawingml/2006/main">
-            <a:off x="7477125" y="2828925"/>
+              <a:t>1</a:t>
+            </a:r>
+          </a:p>
+        </p:txBody>
+      </p:sp>
+      <p:sp>
+        <p:nvSpPr>
+          <p:cNvPr id="21" name="placement-name-0">
+            <a:extLst xmlns:a="http://schemas.openxmlformats.org/drawingml/2006/main">
+              <a:ext uri="{FF2B5EF4-FFF2-40B4-BE49-F238E27FC236}">
+                <a16:creationId xmlns:a16="http://schemas.microsoft.com/office/drawing/2014/main" id="{0997B4DC-4C15-4E4A-BFCE-014EC86070A7}"/>
+              </a:ext>
+            </a:extLst>
+          </p:cNvPr>
+          <p:cNvSpPr>
+            <a:spLocks xmlns:a="http://schemas.openxmlformats.org/drawingml/2006/main" noGrp="1"/>
+          </p:cNvSpPr>
+          <p:nvPr/>
+        </p:nvSpPr>
+        <p:spPr>
+          <a:xfrm xmlns:a="http://schemas.openxmlformats.org/drawingml/2006/main">
+            <a:off x="7877175" y="2924175"/>
+            <a:ext cx="2667000" cy="323850"/>
+          </a:xfrm>
+          <a:prstGeom xmlns:a="http://schemas.openxmlformats.org/drawingml/2006/main" prst="rect">
+            <a:avLst/>
+          </a:prstGeom>
+        </p:spPr>
+        <p:txBody>
+          <a:bodyPr xmlns:a="http://schemas.openxmlformats.org/drawingml/2006/main" wrap="none" lIns="0" tIns="0" rIns="0" bIns="0" anchor="ctr"/>
+          <a:lstStyle xmlns:a="http://schemas.openxmlformats.org/drawingml/2006/main"/>
+          <a:p xmlns:a="http://schemas.openxmlformats.org/drawingml/2006/main">
+            <a:pPr algn="l">
+              <a:buNone/>
+              <a:defRPr sz="1725" b="0">
+                <a:solidFill>
+                  <a:srgbClr val="102E38"/>
+                </a:solidFill>
+                <a:latin typeface="Arial"/>
+                <a:ea typeface="Arial"/>
+                <a:cs typeface="Arial"/>
+              </a:defRPr>
+            </a:pPr>
+            <a:r>
+              <a:rPr sz="1725" b="0">
+                <a:solidFill>
+                  <a:srgbClr val="102E38"/>
+                </a:solidFill>
+                <a:latin typeface="Arial"/>
+                <a:ea typeface="Arial"/>
+                <a:cs typeface="Arial"/>
+              </a:rPr>
+              <a:t>Upper arm</a:t>
+            </a:r>
+          </a:p>
+        </p:txBody>
+      </p:sp>
+      <p:sp>
+        <p:nvSpPr>
+          <p:cNvPr id="22" name="placement-slots-0">
+            <a:extLst xmlns:a="http://schemas.openxmlformats.org/drawingml/2006/main">
+              <a:ext uri="{FF2B5EF4-FFF2-40B4-BE49-F238E27FC236}">
+                <a16:creationId xmlns:a16="http://schemas.microsoft.com/office/drawing/2014/main" id="{0AD487C4-C074-4AF8-AAA7-1F3E7F51633C}"/>
+              </a:ext>
+            </a:extLst>
+          </p:cNvPr>
+          <p:cNvSpPr>
+            <a:spLocks xmlns:a="http://schemas.openxmlformats.org/drawingml/2006/main" noGrp="1"/>
+          </p:cNvSpPr>
+          <p:nvPr/>
+        </p:nvSpPr>
+        <p:spPr>
+          <a:xfrm xmlns:a="http://schemas.openxmlformats.org/drawingml/2006/main">
+            <a:off x="11239500" y="2924175"/>
+            <a:ext cx="685800" cy="323850"/>
+          </a:xfrm>
+          <a:prstGeom xmlns:a="http://schemas.openxmlformats.org/drawingml/2006/main" prst="rect">
+            <a:avLst/>
+          </a:prstGeom>
+        </p:spPr>
+        <p:txBody>
+          <a:bodyPr xmlns:a="http://schemas.openxmlformats.org/drawingml/2006/main" wrap="none" lIns="0" tIns="0" rIns="0" bIns="0" anchor="ctr"/>
+          <a:lstStyle xmlns:a="http://schemas.openxmlformats.org/drawingml/2006/main"/>
+          <a:p xmlns:a="http://schemas.openxmlformats.org/drawingml/2006/main">
+            <a:pPr algn="ctr">
+              <a:buNone/>
+              <a:defRPr sz="1575" b="0">
+                <a:solidFill>
+                  <a:srgbClr val="102E38"/>
+                </a:solidFill>
+                <a:latin typeface="Arial"/>
+                <a:ea typeface="Arial"/>
+                <a:cs typeface="Arial"/>
+              </a:defRPr>
+            </a:pPr>
+            <a:r>
+              <a:rPr sz="1575" b="0">
+                <a:solidFill>
+                  <a:srgbClr val="102E38"/>
+                </a:solidFill>
+                <a:latin typeface="Arial"/>
+                <a:ea typeface="Arial"/>
+                <a:cs typeface="Arial"/>
+              </a:rPr>
+              <a:t>2</a:t>
+            </a:r>
+          </a:p>
+        </p:txBody>
+      </p:sp>
+      <p:sp>
+        <p:nvSpPr>
+          <p:cNvPr id="23" name="placement-price-0">
+            <a:extLst xmlns:a="http://schemas.openxmlformats.org/drawingml/2006/main">
+              <a:ext uri="{FF2B5EF4-FFF2-40B4-BE49-F238E27FC236}">
+                <a16:creationId xmlns:a16="http://schemas.microsoft.com/office/drawing/2014/main" id="{B7B4BE8E-4B2B-4428-AAC8-A457EBBE4A01}"/>
+              </a:ext>
+            </a:extLst>
+          </p:cNvPr>
+          <p:cNvSpPr>
+            <a:spLocks xmlns:a="http://schemas.openxmlformats.org/drawingml/2006/main" noGrp="1"/>
+          </p:cNvSpPr>
+          <p:nvPr/>
+        </p:nvSpPr>
+        <p:spPr>
+          <a:xfrm xmlns:a="http://schemas.openxmlformats.org/drawingml/2006/main">
+            <a:off x="13239750" y="2924175"/>
+            <a:ext cx="1419225" cy="323850"/>
+          </a:xfrm>
+          <a:prstGeom xmlns:a="http://schemas.openxmlformats.org/drawingml/2006/main" prst="rect">
+            <a:avLst/>
+          </a:prstGeom>
+        </p:spPr>
+        <p:txBody>
+          <a:bodyPr xmlns:a="http://schemas.openxmlformats.org/drawingml/2006/main" wrap="none" lIns="0" tIns="0" rIns="0" bIns="0" anchor="ctr"/>
+          <a:lstStyle xmlns:a="http://schemas.openxmlformats.org/drawingml/2006/main"/>
+          <a:p xmlns:a="http://schemas.openxmlformats.org/drawingml/2006/main">
+            <a:pPr algn="r">
+              <a:buNone/>
+              <a:defRPr sz="1725" b="0">
+                <a:solidFill>
+                  <a:srgbClr val="102E38"/>
+                </a:solidFill>
+                <a:latin typeface="Georgia"/>
+                <a:ea typeface="Georgia"/>
+                <a:cs typeface="Georgia"/>
+              </a:defRPr>
+            </a:pPr>
+            <a:r>
+              <a:rPr sz="1725" b="0">
+                <a:solidFill>
+                  <a:srgbClr val="102E38"/>
+                </a:solidFill>
+                <a:latin typeface="Georgia"/>
+                <a:ea typeface="Georgia"/>
+                <a:cs typeface="Georgia"/>
+              </a:rPr>
+              <a:t>$4,000</a:t>
+            </a:r>
+          </a:p>
+        </p:txBody>
+      </p:sp>
+      <p:sp>
+        <p:nvSpPr>
+          <p:cNvPr id="25" name="row-rule-1">
+            <a:extLst xmlns:a="http://schemas.openxmlformats.org/drawingml/2006/main">
+              <a:ext uri="{FF2B5EF4-FFF2-40B4-BE49-F238E27FC236}">
+                <a16:creationId xmlns:a16="http://schemas.microsoft.com/office/drawing/2014/main" id="{E30CC1FC-473A-4698-A87D-4A041FE0EFDB}"/>
+              </a:ext>
+            </a:extLst>
+          </p:cNvPr>
+          <p:cNvSpPr>
+            <a:spLocks xmlns:a="http://schemas.openxmlformats.org/drawingml/2006/main" noGrp="1"/>
+          </p:cNvSpPr>
+          <p:nvPr/>
+        </p:nvSpPr>
+        <p:spPr>
+          <a:xfrm xmlns:a="http://schemas.openxmlformats.org/drawingml/2006/main">
+            <a:off x="7477125" y="3381375"/>
             <a:ext cx="7181850" cy="9525"/>
           </a:xfrm>
           <a:prstGeom xmlns:a="http://schemas.openxmlformats.org/drawingml/2006/main" prst="rect">
@@ -1680,21 +1876,21 @@
       </p:sp>
       <p:sp>
         <p:nvSpPr>
-          <p:cNvPr id="20" name="placement-number-0">
-            <a:extLst xmlns:a="http://schemas.openxmlformats.org/drawingml/2006/main">
-              <a:ext uri="{FF2B5EF4-FFF2-40B4-BE49-F238E27FC236}">
-                <a16:creationId xmlns:a16="http://schemas.microsoft.com/office/drawing/2014/main" id="{F0CDCDA2-FD2C-4FDF-B88D-57F89C74CD06}"/>
-              </a:ext>
-            </a:extLst>
-          </p:cNvPr>
-          <p:cNvSpPr>
-            <a:spLocks xmlns:a="http://schemas.openxmlformats.org/drawingml/2006/main" noGrp="1"/>
-          </p:cNvSpPr>
-          <p:nvPr/>
-        </p:nvSpPr>
-        <p:spPr>
-          <a:xfrm xmlns:a="http://schemas.openxmlformats.org/drawingml/2006/main">
-            <a:off x="7496175" y="2952750"/>
+          <p:cNvPr id="26" name="placement-number-1">
+            <a:extLst xmlns:a="http://schemas.openxmlformats.org/drawingml/2006/main">
+              <a:ext uri="{FF2B5EF4-FFF2-40B4-BE49-F238E27FC236}">
+                <a16:creationId xmlns:a16="http://schemas.microsoft.com/office/drawing/2014/main" id="{8DB0BDAC-9E34-44E0-AE3E-4EFAEDE2B519}"/>
+              </a:ext>
+            </a:extLst>
+          </p:cNvPr>
+          <p:cNvSpPr>
+            <a:spLocks xmlns:a="http://schemas.openxmlformats.org/drawingml/2006/main" noGrp="1"/>
+          </p:cNvSpPr>
+          <p:nvPr/>
+        </p:nvSpPr>
+        <p:spPr>
+          <a:xfrm xmlns:a="http://schemas.openxmlformats.org/drawingml/2006/main">
+            <a:off x="7496175" y="3505200"/>
             <a:ext cx="266700" cy="285750"/>
           </a:xfrm>
           <a:prstGeom xmlns:a="http://schemas.openxmlformats.org/drawingml/2006/main" prst="rect">
@@ -1706,6 +1902,7 @@
           <a:lstStyle xmlns:a="http://schemas.openxmlformats.org/drawingml/2006/main"/>
           <a:p xmlns:a="http://schemas.openxmlformats.org/drawingml/2006/main">
             <a:pPr algn="l">
+              <a:buNone/>
               <a:defRPr sz="1125" b="0">
                 <a:solidFill>
                   <a:srgbClr val="56686A"/>
@@ -1724,28 +1921,28 @@
                 <a:ea typeface="Courier New"/>
                 <a:cs typeface="Courier New"/>
               </a:rPr>
-              <a:t>1</a:t>
-            </a:r>
-          </a:p>
-        </p:txBody>
-      </p:sp>
-      <p:sp>
-        <p:nvSpPr>
-          <p:cNvPr id="21" name="placement-name-0">
-            <a:extLst xmlns:a="http://schemas.openxmlformats.org/drawingml/2006/main">
-              <a:ext uri="{FF2B5EF4-FFF2-40B4-BE49-F238E27FC236}">
-                <a16:creationId xmlns:a16="http://schemas.microsoft.com/office/drawing/2014/main" id="{0997B4DC-4C15-4E4A-BFCE-014EC86070A7}"/>
-              </a:ext>
-            </a:extLst>
-          </p:cNvPr>
-          <p:cNvSpPr>
-            <a:spLocks xmlns:a="http://schemas.openxmlformats.org/drawingml/2006/main" noGrp="1"/>
-          </p:cNvSpPr>
-          <p:nvPr/>
-        </p:nvSpPr>
-        <p:spPr>
-          <a:xfrm xmlns:a="http://schemas.openxmlformats.org/drawingml/2006/main">
-            <a:off x="7877175" y="2924175"/>
+              <a:t>2</a:t>
+            </a:r>
+          </a:p>
+        </p:txBody>
+      </p:sp>
+      <p:sp>
+        <p:nvSpPr>
+          <p:cNvPr id="27" name="placement-name-1">
+            <a:extLst xmlns:a="http://schemas.openxmlformats.org/drawingml/2006/main">
+              <a:ext uri="{FF2B5EF4-FFF2-40B4-BE49-F238E27FC236}">
+                <a16:creationId xmlns:a16="http://schemas.microsoft.com/office/drawing/2014/main" id="{CEB00866-5939-4A2A-A557-310982609759}"/>
+              </a:ext>
+            </a:extLst>
+          </p:cNvPr>
+          <p:cNvSpPr>
+            <a:spLocks xmlns:a="http://schemas.openxmlformats.org/drawingml/2006/main" noGrp="1"/>
+          </p:cNvSpPr>
+          <p:nvPr/>
+        </p:nvSpPr>
+        <p:spPr>
+          <a:xfrm xmlns:a="http://schemas.openxmlformats.org/drawingml/2006/main">
+            <a:off x="7877175" y="3476625"/>
             <a:ext cx="2667000" cy="323850"/>
           </a:xfrm>
           <a:prstGeom xmlns:a="http://schemas.openxmlformats.org/drawingml/2006/main" prst="rect">
@@ -1757,6 +1954,7 @@
           <a:lstStyle xmlns:a="http://schemas.openxmlformats.org/drawingml/2006/main"/>
           <a:p xmlns:a="http://schemas.openxmlformats.org/drawingml/2006/main">
             <a:pPr algn="l">
+              <a:buNone/>
               <a:defRPr sz="1725" b="0">
                 <a:solidFill>
                   <a:srgbClr val="102E38"/>
@@ -1775,28 +1973,28 @@
                 <a:ea typeface="Arial"/>
                 <a:cs typeface="Arial"/>
               </a:rPr>
-              <a:t>Upper arm</a:t>
-            </a:r>
-          </a:p>
-        </p:txBody>
-      </p:sp>
-      <p:sp>
-        <p:nvSpPr>
-          <p:cNvPr id="22" name="placement-slots-0">
-            <a:extLst xmlns:a="http://schemas.openxmlformats.org/drawingml/2006/main">
-              <a:ext uri="{FF2B5EF4-FFF2-40B4-BE49-F238E27FC236}">
-                <a16:creationId xmlns:a16="http://schemas.microsoft.com/office/drawing/2014/main" id="{0AD487C4-C074-4AF8-AAA7-1F3E7F51633C}"/>
-              </a:ext>
-            </a:extLst>
-          </p:cNvPr>
-          <p:cNvSpPr>
-            <a:spLocks xmlns:a="http://schemas.openxmlformats.org/drawingml/2006/main" noGrp="1"/>
-          </p:cNvSpPr>
-          <p:nvPr/>
-        </p:nvSpPr>
-        <p:spPr>
-          <a:xfrm xmlns:a="http://schemas.openxmlformats.org/drawingml/2006/main">
-            <a:off x="10668000" y="2924175"/>
+              <a:t>Middle arm</a:t>
+            </a:r>
+          </a:p>
+        </p:txBody>
+      </p:sp>
+      <p:sp>
+        <p:nvSpPr>
+          <p:cNvPr id="28" name="placement-slots-1">
+            <a:extLst xmlns:a="http://schemas.openxmlformats.org/drawingml/2006/main">
+              <a:ext uri="{FF2B5EF4-FFF2-40B4-BE49-F238E27FC236}">
+                <a16:creationId xmlns:a16="http://schemas.microsoft.com/office/drawing/2014/main" id="{8E89E10D-4E98-44BE-9CD2-69E8B2B77D76}"/>
+              </a:ext>
+            </a:extLst>
+          </p:cNvPr>
+          <p:cNvSpPr>
+            <a:spLocks xmlns:a="http://schemas.openxmlformats.org/drawingml/2006/main" noGrp="1"/>
+          </p:cNvSpPr>
+          <p:nvPr/>
+        </p:nvSpPr>
+        <p:spPr>
+          <a:xfrm xmlns:a="http://schemas.openxmlformats.org/drawingml/2006/main">
+            <a:off x="11239500" y="3476625"/>
             <a:ext cx="685800" cy="323850"/>
           </a:xfrm>
           <a:prstGeom xmlns:a="http://schemas.openxmlformats.org/drawingml/2006/main" prst="rect">
@@ -1808,6 +2006,7 @@
           <a:lstStyle xmlns:a="http://schemas.openxmlformats.org/drawingml/2006/main"/>
           <a:p xmlns:a="http://schemas.openxmlformats.org/drawingml/2006/main">
             <a:pPr algn="ctr">
+              <a:buNone/>
               <a:defRPr sz="1575" b="0">
                 <a:solidFill>
                   <a:srgbClr val="102E38"/>
@@ -1833,22 +2032,22 @@
       </p:sp>
       <p:sp>
         <p:nvSpPr>
-          <p:cNvPr id="23" name="placement-price-0">
-            <a:extLst xmlns:a="http://schemas.openxmlformats.org/drawingml/2006/main">
-              <a:ext uri="{FF2B5EF4-FFF2-40B4-BE49-F238E27FC236}">
-                <a16:creationId xmlns:a16="http://schemas.microsoft.com/office/drawing/2014/main" id="{B7B4BE8E-4B2B-4428-AAC8-A457EBBE4A01}"/>
-              </a:ext>
-            </a:extLst>
-          </p:cNvPr>
-          <p:cNvSpPr>
-            <a:spLocks xmlns:a="http://schemas.openxmlformats.org/drawingml/2006/main" noGrp="1"/>
-          </p:cNvSpPr>
-          <p:nvPr/>
-        </p:nvSpPr>
-        <p:spPr>
-          <a:xfrm xmlns:a="http://schemas.openxmlformats.org/drawingml/2006/main">
-            <a:off x="11620500" y="2924175"/>
-            <a:ext cx="1314450" cy="323850"/>
+          <p:cNvPr id="29" name="placement-price-1">
+            <a:extLst xmlns:a="http://schemas.openxmlformats.org/drawingml/2006/main">
+              <a:ext uri="{FF2B5EF4-FFF2-40B4-BE49-F238E27FC236}">
+                <a16:creationId xmlns:a16="http://schemas.microsoft.com/office/drawing/2014/main" id="{B942C841-4660-4259-AB12-AF83917DB8CB}"/>
+              </a:ext>
+            </a:extLst>
+          </p:cNvPr>
+          <p:cNvSpPr>
+            <a:spLocks xmlns:a="http://schemas.openxmlformats.org/drawingml/2006/main" noGrp="1"/>
+          </p:cNvSpPr>
+          <p:nvPr/>
+        </p:nvSpPr>
+        <p:spPr>
+          <a:xfrm xmlns:a="http://schemas.openxmlformats.org/drawingml/2006/main">
+            <a:off x="13239750" y="3476625"/>
+            <a:ext cx="1419225" cy="323850"/>
           </a:xfrm>
           <a:prstGeom xmlns:a="http://schemas.openxmlformats.org/drawingml/2006/main" prst="rect">
             <a:avLst/>
@@ -1859,6 +2058,7 @@
           <a:lstStyle xmlns:a="http://schemas.openxmlformats.org/drawingml/2006/main"/>
           <a:p xmlns:a="http://schemas.openxmlformats.org/drawingml/2006/main">
             <a:pPr algn="r">
+              <a:buNone/>
               <a:defRPr sz="1725" b="0">
                 <a:solidFill>
                   <a:srgbClr val="102E38"/>
@@ -1877,28 +2077,211 @@
                 <a:ea typeface="Georgia"/>
                 <a:cs typeface="Georgia"/>
               </a:rPr>
-              <a:t>$4,000</a:t>
-            </a:r>
-          </a:p>
-        </p:txBody>
-      </p:sp>
-      <p:sp>
-        <p:nvSpPr>
-          <p:cNvPr id="24" name="placement-revenue-0">
-            <a:extLst xmlns:a="http://schemas.openxmlformats.org/drawingml/2006/main">
-              <a:ext uri="{FF2B5EF4-FFF2-40B4-BE49-F238E27FC236}">
-                <a16:creationId xmlns:a16="http://schemas.microsoft.com/office/drawing/2014/main" id="{9D27FC19-7613-455F-9FE2-D5D1896ABB29}"/>
-              </a:ext>
-            </a:extLst>
-          </p:cNvPr>
-          <p:cNvSpPr>
-            <a:spLocks xmlns:a="http://schemas.openxmlformats.org/drawingml/2006/main" noGrp="1"/>
-          </p:cNvSpPr>
-          <p:nvPr/>
-        </p:nvSpPr>
-        <p:spPr>
-          <a:xfrm xmlns:a="http://schemas.openxmlformats.org/drawingml/2006/main">
-            <a:off x="13239750" y="2924175"/>
+              <a:t>$3,500</a:t>
+            </a:r>
+          </a:p>
+        </p:txBody>
+      </p:sp>
+      <p:sp>
+        <p:nvSpPr>
+          <p:cNvPr id="31" name="row-rule-2">
+            <a:extLst xmlns:a="http://schemas.openxmlformats.org/drawingml/2006/main">
+              <a:ext uri="{FF2B5EF4-FFF2-40B4-BE49-F238E27FC236}">
+                <a16:creationId xmlns:a16="http://schemas.microsoft.com/office/drawing/2014/main" id="{DBC87FF7-969C-4996-B222-265857C40945}"/>
+              </a:ext>
+            </a:extLst>
+          </p:cNvPr>
+          <p:cNvSpPr>
+            <a:spLocks xmlns:a="http://schemas.openxmlformats.org/drawingml/2006/main" noGrp="1"/>
+          </p:cNvSpPr>
+          <p:nvPr/>
+        </p:nvSpPr>
+        <p:spPr>
+          <a:xfrm xmlns:a="http://schemas.openxmlformats.org/drawingml/2006/main">
+            <a:off x="7477125" y="3933825"/>
+            <a:ext cx="7181850" cy="9525"/>
+          </a:xfrm>
+          <a:prstGeom xmlns:a="http://schemas.openxmlformats.org/drawingml/2006/main" prst="rect">
+            <a:avLst/>
+          </a:prstGeom>
+          <a:solidFill xmlns:a="http://schemas.openxmlformats.org/drawingml/2006/main">
+            <a:srgbClr val="BCAD86"/>
+          </a:solidFill>
+        </p:spPr>
+      </p:sp>
+      <p:sp>
+        <p:nvSpPr>
+          <p:cNvPr id="32" name="placement-number-2">
+            <a:extLst xmlns:a="http://schemas.openxmlformats.org/drawingml/2006/main">
+              <a:ext uri="{FF2B5EF4-FFF2-40B4-BE49-F238E27FC236}">
+                <a16:creationId xmlns:a16="http://schemas.microsoft.com/office/drawing/2014/main" id="{11E37F26-C640-40A5-A56F-EDBACEAAE441}"/>
+              </a:ext>
+            </a:extLst>
+          </p:cNvPr>
+          <p:cNvSpPr>
+            <a:spLocks xmlns:a="http://schemas.openxmlformats.org/drawingml/2006/main" noGrp="1"/>
+          </p:cNvSpPr>
+          <p:nvPr/>
+        </p:nvSpPr>
+        <p:spPr>
+          <a:xfrm xmlns:a="http://schemas.openxmlformats.org/drawingml/2006/main">
+            <a:off x="7496175" y="4057650"/>
+            <a:ext cx="266700" cy="285750"/>
+          </a:xfrm>
+          <a:prstGeom xmlns:a="http://schemas.openxmlformats.org/drawingml/2006/main" prst="rect">
+            <a:avLst/>
+          </a:prstGeom>
+        </p:spPr>
+        <p:txBody>
+          <a:bodyPr xmlns:a="http://schemas.openxmlformats.org/drawingml/2006/main" wrap="none" lIns="0" tIns="0" rIns="0" bIns="0" anchor="ctr"/>
+          <a:lstStyle xmlns:a="http://schemas.openxmlformats.org/drawingml/2006/main"/>
+          <a:p xmlns:a="http://schemas.openxmlformats.org/drawingml/2006/main">
+            <a:pPr algn="l">
+              <a:buNone/>
+              <a:defRPr sz="1125" b="0">
+                <a:solidFill>
+                  <a:srgbClr val="56686A"/>
+                </a:solidFill>
+                <a:latin typeface="Courier New"/>
+                <a:ea typeface="Courier New"/>
+                <a:cs typeface="Courier New"/>
+              </a:defRPr>
+            </a:pPr>
+            <a:r>
+              <a:rPr sz="1125" b="0">
+                <a:solidFill>
+                  <a:srgbClr val="56686A"/>
+                </a:solidFill>
+                <a:latin typeface="Courier New"/>
+                <a:ea typeface="Courier New"/>
+                <a:cs typeface="Courier New"/>
+              </a:rPr>
+              <a:t>3</a:t>
+            </a:r>
+          </a:p>
+        </p:txBody>
+      </p:sp>
+      <p:sp>
+        <p:nvSpPr>
+          <p:cNvPr id="33" name="placement-name-2">
+            <a:extLst xmlns:a="http://schemas.openxmlformats.org/drawingml/2006/main">
+              <a:ext uri="{FF2B5EF4-FFF2-40B4-BE49-F238E27FC236}">
+                <a16:creationId xmlns:a16="http://schemas.microsoft.com/office/drawing/2014/main" id="{FA72C90D-648C-4452-8FC7-D64602600F3E}"/>
+              </a:ext>
+            </a:extLst>
+          </p:cNvPr>
+          <p:cNvSpPr>
+            <a:spLocks xmlns:a="http://schemas.openxmlformats.org/drawingml/2006/main" noGrp="1"/>
+          </p:cNvSpPr>
+          <p:nvPr/>
+        </p:nvSpPr>
+        <p:spPr>
+          <a:xfrm xmlns:a="http://schemas.openxmlformats.org/drawingml/2006/main">
+            <a:off x="7877175" y="4029075"/>
+            <a:ext cx="2667000" cy="323850"/>
+          </a:xfrm>
+          <a:prstGeom xmlns:a="http://schemas.openxmlformats.org/drawingml/2006/main" prst="rect">
+            <a:avLst/>
+          </a:prstGeom>
+        </p:spPr>
+        <p:txBody>
+          <a:bodyPr xmlns:a="http://schemas.openxmlformats.org/drawingml/2006/main" wrap="none" lIns="0" tIns="0" rIns="0" bIns="0" anchor="ctr"/>
+          <a:lstStyle xmlns:a="http://schemas.openxmlformats.org/drawingml/2006/main"/>
+          <a:p xmlns:a="http://schemas.openxmlformats.org/drawingml/2006/main">
+            <a:pPr algn="l">
+              <a:buNone/>
+              <a:defRPr sz="1725" b="0">
+                <a:solidFill>
+                  <a:srgbClr val="102E38"/>
+                </a:solidFill>
+                <a:latin typeface="Arial"/>
+                <a:ea typeface="Arial"/>
+                <a:cs typeface="Arial"/>
+              </a:defRPr>
+            </a:pPr>
+            <a:r>
+              <a:rPr sz="1725" b="0">
+                <a:solidFill>
+                  <a:srgbClr val="102E38"/>
+                </a:solidFill>
+                <a:latin typeface="Arial"/>
+                <a:ea typeface="Arial"/>
+                <a:cs typeface="Arial"/>
+              </a:rPr>
+              <a:t>Lower arm</a:t>
+            </a:r>
+          </a:p>
+        </p:txBody>
+      </p:sp>
+      <p:sp>
+        <p:nvSpPr>
+          <p:cNvPr id="34" name="placement-slots-2">
+            <a:extLst xmlns:a="http://schemas.openxmlformats.org/drawingml/2006/main">
+              <a:ext uri="{FF2B5EF4-FFF2-40B4-BE49-F238E27FC236}">
+                <a16:creationId xmlns:a16="http://schemas.microsoft.com/office/drawing/2014/main" id="{3FF2B899-50ED-4566-B3DB-D1F3797FDE64}"/>
+              </a:ext>
+            </a:extLst>
+          </p:cNvPr>
+          <p:cNvSpPr>
+            <a:spLocks xmlns:a="http://schemas.openxmlformats.org/drawingml/2006/main" noGrp="1"/>
+          </p:cNvSpPr>
+          <p:nvPr/>
+        </p:nvSpPr>
+        <p:spPr>
+          <a:xfrm xmlns:a="http://schemas.openxmlformats.org/drawingml/2006/main">
+            <a:off x="11239500" y="4029075"/>
+            <a:ext cx="685800" cy="323850"/>
+          </a:xfrm>
+          <a:prstGeom xmlns:a="http://schemas.openxmlformats.org/drawingml/2006/main" prst="rect">
+            <a:avLst/>
+          </a:prstGeom>
+        </p:spPr>
+        <p:txBody>
+          <a:bodyPr xmlns:a="http://schemas.openxmlformats.org/drawingml/2006/main" wrap="none" lIns="0" tIns="0" rIns="0" bIns="0" anchor="ctr"/>
+          <a:lstStyle xmlns:a="http://schemas.openxmlformats.org/drawingml/2006/main"/>
+          <a:p xmlns:a="http://schemas.openxmlformats.org/drawingml/2006/main">
+            <a:pPr algn="ctr">
+              <a:buNone/>
+              <a:defRPr sz="1575" b="0">
+                <a:solidFill>
+                  <a:srgbClr val="102E38"/>
+                </a:solidFill>
+                <a:latin typeface="Arial"/>
+                <a:ea typeface="Arial"/>
+                <a:cs typeface="Arial"/>
+              </a:defRPr>
+            </a:pPr>
+            <a:r>
+              <a:rPr sz="1575" b="0">
+                <a:solidFill>
+                  <a:srgbClr val="102E38"/>
+                </a:solidFill>
+                <a:latin typeface="Arial"/>
+                <a:ea typeface="Arial"/>
+                <a:cs typeface="Arial"/>
+              </a:rPr>
+              <a:t>2</a:t>
+            </a:r>
+          </a:p>
+        </p:txBody>
+      </p:sp>
+      <p:sp>
+        <p:nvSpPr>
+          <p:cNvPr id="35" name="placement-price-2">
+            <a:extLst xmlns:a="http://schemas.openxmlformats.org/drawingml/2006/main">
+              <a:ext uri="{FF2B5EF4-FFF2-40B4-BE49-F238E27FC236}">
+                <a16:creationId xmlns:a16="http://schemas.microsoft.com/office/drawing/2014/main" id="{7159A623-F2C1-4E10-A16B-4D2718F24CCE}"/>
+              </a:ext>
+            </a:extLst>
+          </p:cNvPr>
+          <p:cNvSpPr>
+            <a:spLocks xmlns:a="http://schemas.openxmlformats.org/drawingml/2006/main" noGrp="1"/>
+          </p:cNvSpPr>
+          <p:nvPr/>
+        </p:nvSpPr>
+        <p:spPr>
+          <a:xfrm xmlns:a="http://schemas.openxmlformats.org/drawingml/2006/main">
+            <a:off x="13239750" y="4029075"/>
             <a:ext cx="1419225" cy="323850"/>
           </a:xfrm>
           <a:prstGeom xmlns:a="http://schemas.openxmlformats.org/drawingml/2006/main" prst="rect">
@@ -1910,6 +2293,7 @@
           <a:lstStyle xmlns:a="http://schemas.openxmlformats.org/drawingml/2006/main"/>
           <a:p xmlns:a="http://schemas.openxmlformats.org/drawingml/2006/main">
             <a:pPr algn="r">
+              <a:buNone/>
               <a:defRPr sz="1725" b="0">
                 <a:solidFill>
                   <a:srgbClr val="102E38"/>
@@ -1928,28 +2312,28 @@
                 <a:ea typeface="Georgia"/>
                 <a:cs typeface="Georgia"/>
               </a:rPr>
-              <a:t>$8,000</a:t>
-            </a:r>
-          </a:p>
-        </p:txBody>
-      </p:sp>
-      <p:sp>
-        <p:nvSpPr>
-          <p:cNvPr id="25" name="row-rule-1">
-            <a:extLst xmlns:a="http://schemas.openxmlformats.org/drawingml/2006/main">
-              <a:ext uri="{FF2B5EF4-FFF2-40B4-BE49-F238E27FC236}">
-                <a16:creationId xmlns:a16="http://schemas.microsoft.com/office/drawing/2014/main" id="{E30CC1FC-473A-4698-A87D-4A041FE0EFDB}"/>
-              </a:ext>
-            </a:extLst>
-          </p:cNvPr>
-          <p:cNvSpPr>
-            <a:spLocks xmlns:a="http://schemas.openxmlformats.org/drawingml/2006/main" noGrp="1"/>
-          </p:cNvSpPr>
-          <p:nvPr/>
-        </p:nvSpPr>
-        <p:spPr>
-          <a:xfrm xmlns:a="http://schemas.openxmlformats.org/drawingml/2006/main">
-            <a:off x="7477125" y="3381375"/>
+              <a:t>$3,000</a:t>
+            </a:r>
+          </a:p>
+        </p:txBody>
+      </p:sp>
+      <p:sp>
+        <p:nvSpPr>
+          <p:cNvPr id="37" name="row-rule-3">
+            <a:extLst xmlns:a="http://schemas.openxmlformats.org/drawingml/2006/main">
+              <a:ext uri="{FF2B5EF4-FFF2-40B4-BE49-F238E27FC236}">
+                <a16:creationId xmlns:a16="http://schemas.microsoft.com/office/drawing/2014/main" id="{FE927755-550B-41E8-BE68-B34C65B92CE1}"/>
+              </a:ext>
+            </a:extLst>
+          </p:cNvPr>
+          <p:cNvSpPr>
+            <a:spLocks xmlns:a="http://schemas.openxmlformats.org/drawingml/2006/main" noGrp="1"/>
+          </p:cNvSpPr>
+          <p:nvPr/>
+        </p:nvSpPr>
+        <p:spPr>
+          <a:xfrm xmlns:a="http://schemas.openxmlformats.org/drawingml/2006/main">
+            <a:off x="7477125" y="4486275"/>
             <a:ext cx="7181850" cy="9525"/>
           </a:xfrm>
           <a:prstGeom xmlns:a="http://schemas.openxmlformats.org/drawingml/2006/main" prst="rect">
@@ -1962,21 +2346,21 @@
       </p:sp>
       <p:sp>
         <p:nvSpPr>
-          <p:cNvPr id="26" name="placement-number-1">
-            <a:extLst xmlns:a="http://schemas.openxmlformats.org/drawingml/2006/main">
-              <a:ext uri="{FF2B5EF4-FFF2-40B4-BE49-F238E27FC236}">
-                <a16:creationId xmlns:a16="http://schemas.microsoft.com/office/drawing/2014/main" id="{8DB0BDAC-9E34-44E0-AE3E-4EFAEDE2B519}"/>
-              </a:ext>
-            </a:extLst>
-          </p:cNvPr>
-          <p:cNvSpPr>
-            <a:spLocks xmlns:a="http://schemas.openxmlformats.org/drawingml/2006/main" noGrp="1"/>
-          </p:cNvSpPr>
-          <p:nvPr/>
-        </p:nvSpPr>
-        <p:spPr>
-          <a:xfrm xmlns:a="http://schemas.openxmlformats.org/drawingml/2006/main">
-            <a:off x="7496175" y="3505200"/>
+          <p:cNvPr id="38" name="placement-number-3">
+            <a:extLst xmlns:a="http://schemas.openxmlformats.org/drawingml/2006/main">
+              <a:ext uri="{FF2B5EF4-FFF2-40B4-BE49-F238E27FC236}">
+                <a16:creationId xmlns:a16="http://schemas.microsoft.com/office/drawing/2014/main" id="{3238E5EB-FA09-4B8C-BCE3-4497DA39F0F8}"/>
+              </a:ext>
+            </a:extLst>
+          </p:cNvPr>
+          <p:cNvSpPr>
+            <a:spLocks xmlns:a="http://schemas.openxmlformats.org/drawingml/2006/main" noGrp="1"/>
+          </p:cNvSpPr>
+          <p:nvPr/>
+        </p:nvSpPr>
+        <p:spPr>
+          <a:xfrm xmlns:a="http://schemas.openxmlformats.org/drawingml/2006/main">
+            <a:off x="7496175" y="4610100"/>
             <a:ext cx="266700" cy="285750"/>
           </a:xfrm>
           <a:prstGeom xmlns:a="http://schemas.openxmlformats.org/drawingml/2006/main" prst="rect">
@@ -1988,6 +2372,7 @@
           <a:lstStyle xmlns:a="http://schemas.openxmlformats.org/drawingml/2006/main"/>
           <a:p xmlns:a="http://schemas.openxmlformats.org/drawingml/2006/main">
             <a:pPr algn="l">
+              <a:buNone/>
               <a:defRPr sz="1125" b="0">
                 <a:solidFill>
                   <a:srgbClr val="56686A"/>
@@ -2006,28 +2391,28 @@
                 <a:ea typeface="Courier New"/>
                 <a:cs typeface="Courier New"/>
               </a:rPr>
-              <a:t>2</a:t>
-            </a:r>
-          </a:p>
-        </p:txBody>
-      </p:sp>
-      <p:sp>
-        <p:nvSpPr>
-          <p:cNvPr id="27" name="placement-name-1">
-            <a:extLst xmlns:a="http://schemas.openxmlformats.org/drawingml/2006/main">
-              <a:ext uri="{FF2B5EF4-FFF2-40B4-BE49-F238E27FC236}">
-                <a16:creationId xmlns:a16="http://schemas.microsoft.com/office/drawing/2014/main" id="{CEB00866-5939-4A2A-A557-310982609759}"/>
-              </a:ext>
-            </a:extLst>
-          </p:cNvPr>
-          <p:cNvSpPr>
-            <a:spLocks xmlns:a="http://schemas.openxmlformats.org/drawingml/2006/main" noGrp="1"/>
-          </p:cNvSpPr>
-          <p:nvPr/>
-        </p:nvSpPr>
-        <p:spPr>
-          <a:xfrm xmlns:a="http://schemas.openxmlformats.org/drawingml/2006/main">
-            <a:off x="7877175" y="3476625"/>
+              <a:t>4</a:t>
+            </a:r>
+          </a:p>
+        </p:txBody>
+      </p:sp>
+      <p:sp>
+        <p:nvSpPr>
+          <p:cNvPr id="39" name="placement-name-3">
+            <a:extLst xmlns:a="http://schemas.openxmlformats.org/drawingml/2006/main">
+              <a:ext uri="{FF2B5EF4-FFF2-40B4-BE49-F238E27FC236}">
+                <a16:creationId xmlns:a16="http://schemas.microsoft.com/office/drawing/2014/main" id="{37624AFC-AB39-4E42-BCA1-7448D02FAC03}"/>
+              </a:ext>
+            </a:extLst>
+          </p:cNvPr>
+          <p:cNvSpPr>
+            <a:spLocks xmlns:a="http://schemas.openxmlformats.org/drawingml/2006/main" noGrp="1"/>
+          </p:cNvSpPr>
+          <p:nvPr/>
+        </p:nvSpPr>
+        <p:spPr>
+          <a:xfrm xmlns:a="http://schemas.openxmlformats.org/drawingml/2006/main">
+            <a:off x="7877175" y="4581525"/>
             <a:ext cx="2667000" cy="323850"/>
           </a:xfrm>
           <a:prstGeom xmlns:a="http://schemas.openxmlformats.org/drawingml/2006/main" prst="rect">
@@ -2039,6 +2424,7 @@
           <a:lstStyle xmlns:a="http://schemas.openxmlformats.org/drawingml/2006/main"/>
           <a:p xmlns:a="http://schemas.openxmlformats.org/drawingml/2006/main">
             <a:pPr algn="l">
+              <a:buNone/>
               <a:defRPr sz="1725" b="0">
                 <a:solidFill>
                   <a:srgbClr val="102E38"/>
@@ -2057,28 +2443,28 @@
                 <a:ea typeface="Arial"/>
                 <a:cs typeface="Arial"/>
               </a:rPr>
-              <a:t>Middle arm</a:t>
-            </a:r>
-          </a:p>
-        </p:txBody>
-      </p:sp>
-      <p:sp>
-        <p:nvSpPr>
-          <p:cNvPr id="28" name="placement-slots-1">
-            <a:extLst xmlns:a="http://schemas.openxmlformats.org/drawingml/2006/main">
-              <a:ext uri="{FF2B5EF4-FFF2-40B4-BE49-F238E27FC236}">
-                <a16:creationId xmlns:a16="http://schemas.microsoft.com/office/drawing/2014/main" id="{8E89E10D-4E98-44BE-9CD2-69E8B2B77D76}"/>
-              </a:ext>
-            </a:extLst>
-          </p:cNvPr>
-          <p:cNvSpPr>
-            <a:spLocks xmlns:a="http://schemas.openxmlformats.org/drawingml/2006/main" noGrp="1"/>
-          </p:cNvSpPr>
-          <p:nvPr/>
-        </p:nvSpPr>
-        <p:spPr>
-          <a:xfrm xmlns:a="http://schemas.openxmlformats.org/drawingml/2006/main">
-            <a:off x="10668000" y="3476625"/>
+              <a:t>Left chest</a:t>
+            </a:r>
+          </a:p>
+        </p:txBody>
+      </p:sp>
+      <p:sp>
+        <p:nvSpPr>
+          <p:cNvPr id="40" name="placement-slots-3">
+            <a:extLst xmlns:a="http://schemas.openxmlformats.org/drawingml/2006/main">
+              <a:ext uri="{FF2B5EF4-FFF2-40B4-BE49-F238E27FC236}">
+                <a16:creationId xmlns:a16="http://schemas.microsoft.com/office/drawing/2014/main" id="{C3DF1D47-4B49-4F38-BD74-4F1D56E3DA6A}"/>
+              </a:ext>
+            </a:extLst>
+          </p:cNvPr>
+          <p:cNvSpPr>
+            <a:spLocks xmlns:a="http://schemas.openxmlformats.org/drawingml/2006/main" noGrp="1"/>
+          </p:cNvSpPr>
+          <p:nvPr/>
+        </p:nvSpPr>
+        <p:spPr>
+          <a:xfrm xmlns:a="http://schemas.openxmlformats.org/drawingml/2006/main">
+            <a:off x="11239500" y="4581525"/>
             <a:ext cx="685800" cy="323850"/>
           </a:xfrm>
           <a:prstGeom xmlns:a="http://schemas.openxmlformats.org/drawingml/2006/main" prst="rect">
@@ -2090,6 +2476,7 @@
           <a:lstStyle xmlns:a="http://schemas.openxmlformats.org/drawingml/2006/main"/>
           <a:p xmlns:a="http://schemas.openxmlformats.org/drawingml/2006/main">
             <a:pPr algn="ctr">
+              <a:buNone/>
               <a:defRPr sz="1575" b="0">
                 <a:solidFill>
                   <a:srgbClr val="102E38"/>
@@ -2108,29 +2495,29 @@
                 <a:ea typeface="Arial"/>
                 <a:cs typeface="Arial"/>
               </a:rPr>
-              <a:t>2</a:t>
-            </a:r>
-          </a:p>
-        </p:txBody>
-      </p:sp>
-      <p:sp>
-        <p:nvSpPr>
-          <p:cNvPr id="29" name="placement-price-1">
-            <a:extLst xmlns:a="http://schemas.openxmlformats.org/drawingml/2006/main">
-              <a:ext uri="{FF2B5EF4-FFF2-40B4-BE49-F238E27FC236}">
-                <a16:creationId xmlns:a16="http://schemas.microsoft.com/office/drawing/2014/main" id="{B942C841-4660-4259-AB12-AF83917DB8CB}"/>
-              </a:ext>
-            </a:extLst>
-          </p:cNvPr>
-          <p:cNvSpPr>
-            <a:spLocks xmlns:a="http://schemas.openxmlformats.org/drawingml/2006/main" noGrp="1"/>
-          </p:cNvSpPr>
-          <p:nvPr/>
-        </p:nvSpPr>
-        <p:spPr>
-          <a:xfrm xmlns:a="http://schemas.openxmlformats.org/drawingml/2006/main">
-            <a:off x="11620500" y="3476625"/>
-            <a:ext cx="1314450" cy="323850"/>
+              <a:t>1</a:t>
+            </a:r>
+          </a:p>
+        </p:txBody>
+      </p:sp>
+      <p:sp>
+        <p:nvSpPr>
+          <p:cNvPr id="41" name="placement-price-3">
+            <a:extLst xmlns:a="http://schemas.openxmlformats.org/drawingml/2006/main">
+              <a:ext uri="{FF2B5EF4-FFF2-40B4-BE49-F238E27FC236}">
+                <a16:creationId xmlns:a16="http://schemas.microsoft.com/office/drawing/2014/main" id="{ABC306AF-26EE-4EA2-BB3D-C5C1B09C7515}"/>
+              </a:ext>
+            </a:extLst>
+          </p:cNvPr>
+          <p:cNvSpPr>
+            <a:spLocks xmlns:a="http://schemas.openxmlformats.org/drawingml/2006/main" noGrp="1"/>
+          </p:cNvSpPr>
+          <p:nvPr/>
+        </p:nvSpPr>
+        <p:spPr>
+          <a:xfrm xmlns:a="http://schemas.openxmlformats.org/drawingml/2006/main">
+            <a:off x="13239750" y="4581525"/>
+            <a:ext cx="1419225" cy="323850"/>
           </a:xfrm>
           <a:prstGeom xmlns:a="http://schemas.openxmlformats.org/drawingml/2006/main" prst="rect">
             <a:avLst/>
@@ -2141,6 +2528,7 @@
           <a:lstStyle xmlns:a="http://schemas.openxmlformats.org/drawingml/2006/main"/>
           <a:p xmlns:a="http://schemas.openxmlformats.org/drawingml/2006/main">
             <a:pPr algn="r">
+              <a:buNone/>
               <a:defRPr sz="1725" b="0">
                 <a:solidFill>
                   <a:srgbClr val="102E38"/>
@@ -2159,28 +2547,211 @@
                 <a:ea typeface="Georgia"/>
                 <a:cs typeface="Georgia"/>
               </a:rPr>
-              <a:t>$3,500</a:t>
-            </a:r>
-          </a:p>
-        </p:txBody>
-      </p:sp>
-      <p:sp>
-        <p:nvSpPr>
-          <p:cNvPr id="30" name="placement-revenue-1">
-            <a:extLst xmlns:a="http://schemas.openxmlformats.org/drawingml/2006/main">
-              <a:ext uri="{FF2B5EF4-FFF2-40B4-BE49-F238E27FC236}">
-                <a16:creationId xmlns:a16="http://schemas.microsoft.com/office/drawing/2014/main" id="{2C3A4E7B-89B4-41DF-A261-C7157B9412FB}"/>
-              </a:ext>
-            </a:extLst>
-          </p:cNvPr>
-          <p:cNvSpPr>
-            <a:spLocks xmlns:a="http://schemas.openxmlformats.org/drawingml/2006/main" noGrp="1"/>
-          </p:cNvSpPr>
-          <p:nvPr/>
-        </p:nvSpPr>
-        <p:spPr>
-          <a:xfrm xmlns:a="http://schemas.openxmlformats.org/drawingml/2006/main">
-            <a:off x="13239750" y="3476625"/>
+              <a:t>$7,000</a:t>
+            </a:r>
+          </a:p>
+        </p:txBody>
+      </p:sp>
+      <p:sp>
+        <p:nvSpPr>
+          <p:cNvPr id="43" name="row-rule-4">
+            <a:extLst xmlns:a="http://schemas.openxmlformats.org/drawingml/2006/main">
+              <a:ext uri="{FF2B5EF4-FFF2-40B4-BE49-F238E27FC236}">
+                <a16:creationId xmlns:a16="http://schemas.microsoft.com/office/drawing/2014/main" id="{03F8C9ED-9BFA-4266-AE7A-F5691A702EFF}"/>
+              </a:ext>
+            </a:extLst>
+          </p:cNvPr>
+          <p:cNvSpPr>
+            <a:spLocks xmlns:a="http://schemas.openxmlformats.org/drawingml/2006/main" noGrp="1"/>
+          </p:cNvSpPr>
+          <p:nvPr/>
+        </p:nvSpPr>
+        <p:spPr>
+          <a:xfrm xmlns:a="http://schemas.openxmlformats.org/drawingml/2006/main">
+            <a:off x="7477125" y="5038725"/>
+            <a:ext cx="7181850" cy="9525"/>
+          </a:xfrm>
+          <a:prstGeom xmlns:a="http://schemas.openxmlformats.org/drawingml/2006/main" prst="rect">
+            <a:avLst/>
+          </a:prstGeom>
+          <a:solidFill xmlns:a="http://schemas.openxmlformats.org/drawingml/2006/main">
+            <a:srgbClr val="BCAD86"/>
+          </a:solidFill>
+        </p:spPr>
+      </p:sp>
+      <p:sp>
+        <p:nvSpPr>
+          <p:cNvPr id="44" name="placement-number-4">
+            <a:extLst xmlns:a="http://schemas.openxmlformats.org/drawingml/2006/main">
+              <a:ext uri="{FF2B5EF4-FFF2-40B4-BE49-F238E27FC236}">
+                <a16:creationId xmlns:a16="http://schemas.microsoft.com/office/drawing/2014/main" id="{73C457EC-9489-4AC6-BD00-891DBAB1A384}"/>
+              </a:ext>
+            </a:extLst>
+          </p:cNvPr>
+          <p:cNvSpPr>
+            <a:spLocks xmlns:a="http://schemas.openxmlformats.org/drawingml/2006/main" noGrp="1"/>
+          </p:cNvSpPr>
+          <p:nvPr/>
+        </p:nvSpPr>
+        <p:spPr>
+          <a:xfrm xmlns:a="http://schemas.openxmlformats.org/drawingml/2006/main">
+            <a:off x="7496175" y="5162550"/>
+            <a:ext cx="266700" cy="285750"/>
+          </a:xfrm>
+          <a:prstGeom xmlns:a="http://schemas.openxmlformats.org/drawingml/2006/main" prst="rect">
+            <a:avLst/>
+          </a:prstGeom>
+        </p:spPr>
+        <p:txBody>
+          <a:bodyPr xmlns:a="http://schemas.openxmlformats.org/drawingml/2006/main" wrap="none" lIns="0" tIns="0" rIns="0" bIns="0" anchor="ctr"/>
+          <a:lstStyle xmlns:a="http://schemas.openxmlformats.org/drawingml/2006/main"/>
+          <a:p xmlns:a="http://schemas.openxmlformats.org/drawingml/2006/main">
+            <a:pPr algn="l">
+              <a:buNone/>
+              <a:defRPr sz="1125" b="0">
+                <a:solidFill>
+                  <a:srgbClr val="56686A"/>
+                </a:solidFill>
+                <a:latin typeface="Courier New"/>
+                <a:ea typeface="Courier New"/>
+                <a:cs typeface="Courier New"/>
+              </a:defRPr>
+            </a:pPr>
+            <a:r>
+              <a:rPr sz="1125" b="0">
+                <a:solidFill>
+                  <a:srgbClr val="56686A"/>
+                </a:solidFill>
+                <a:latin typeface="Courier New"/>
+                <a:ea typeface="Courier New"/>
+                <a:cs typeface="Courier New"/>
+              </a:rPr>
+              <a:t>5</a:t>
+            </a:r>
+          </a:p>
+        </p:txBody>
+      </p:sp>
+      <p:sp>
+        <p:nvSpPr>
+          <p:cNvPr id="45" name="placement-name-4">
+            <a:extLst xmlns:a="http://schemas.openxmlformats.org/drawingml/2006/main">
+              <a:ext uri="{FF2B5EF4-FFF2-40B4-BE49-F238E27FC236}">
+                <a16:creationId xmlns:a16="http://schemas.microsoft.com/office/drawing/2014/main" id="{16449C19-3B89-4CA3-8CCB-71E4C462DB34}"/>
+              </a:ext>
+            </a:extLst>
+          </p:cNvPr>
+          <p:cNvSpPr>
+            <a:spLocks xmlns:a="http://schemas.openxmlformats.org/drawingml/2006/main" noGrp="1"/>
+          </p:cNvSpPr>
+          <p:nvPr/>
+        </p:nvSpPr>
+        <p:spPr>
+          <a:xfrm xmlns:a="http://schemas.openxmlformats.org/drawingml/2006/main">
+            <a:off x="7877175" y="5133975"/>
+            <a:ext cx="2667000" cy="323850"/>
+          </a:xfrm>
+          <a:prstGeom xmlns:a="http://schemas.openxmlformats.org/drawingml/2006/main" prst="rect">
+            <a:avLst/>
+          </a:prstGeom>
+        </p:spPr>
+        <p:txBody>
+          <a:bodyPr xmlns:a="http://schemas.openxmlformats.org/drawingml/2006/main" wrap="none" lIns="0" tIns="0" rIns="0" bIns="0" anchor="ctr"/>
+          <a:lstStyle xmlns:a="http://schemas.openxmlformats.org/drawingml/2006/main"/>
+          <a:p xmlns:a="http://schemas.openxmlformats.org/drawingml/2006/main">
+            <a:pPr algn="l">
+              <a:buNone/>
+              <a:defRPr sz="1725" b="0">
+                <a:solidFill>
+                  <a:srgbClr val="102E38"/>
+                </a:solidFill>
+                <a:latin typeface="Arial"/>
+                <a:ea typeface="Arial"/>
+                <a:cs typeface="Arial"/>
+              </a:defRPr>
+            </a:pPr>
+            <a:r>
+              <a:rPr sz="1725" b="0">
+                <a:solidFill>
+                  <a:srgbClr val="102E38"/>
+                </a:solidFill>
+                <a:latin typeface="Arial"/>
+                <a:ea typeface="Arial"/>
+                <a:cs typeface="Arial"/>
+              </a:rPr>
+              <a:t>Right front</a:t>
+            </a:r>
+          </a:p>
+        </p:txBody>
+      </p:sp>
+      <p:sp>
+        <p:nvSpPr>
+          <p:cNvPr id="46" name="placement-slots-4">
+            <a:extLst xmlns:a="http://schemas.openxmlformats.org/drawingml/2006/main">
+              <a:ext uri="{FF2B5EF4-FFF2-40B4-BE49-F238E27FC236}">
+                <a16:creationId xmlns:a16="http://schemas.microsoft.com/office/drawing/2014/main" id="{E71A654E-B4F2-40B2-9B65-8293B21C0B6C}"/>
+              </a:ext>
+            </a:extLst>
+          </p:cNvPr>
+          <p:cNvSpPr>
+            <a:spLocks xmlns:a="http://schemas.openxmlformats.org/drawingml/2006/main" noGrp="1"/>
+          </p:cNvSpPr>
+          <p:nvPr/>
+        </p:nvSpPr>
+        <p:spPr>
+          <a:xfrm xmlns:a="http://schemas.openxmlformats.org/drawingml/2006/main">
+            <a:off x="11239500" y="5133975"/>
+            <a:ext cx="685800" cy="323850"/>
+          </a:xfrm>
+          <a:prstGeom xmlns:a="http://schemas.openxmlformats.org/drawingml/2006/main" prst="rect">
+            <a:avLst/>
+          </a:prstGeom>
+        </p:spPr>
+        <p:txBody>
+          <a:bodyPr xmlns:a="http://schemas.openxmlformats.org/drawingml/2006/main" wrap="none" lIns="0" tIns="0" rIns="0" bIns="0" anchor="ctr"/>
+          <a:lstStyle xmlns:a="http://schemas.openxmlformats.org/drawingml/2006/main"/>
+          <a:p xmlns:a="http://schemas.openxmlformats.org/drawingml/2006/main">
+            <a:pPr algn="ctr">
+              <a:buNone/>
+              <a:defRPr sz="1575" b="0">
+                <a:solidFill>
+                  <a:srgbClr val="102E38"/>
+                </a:solidFill>
+                <a:latin typeface="Arial"/>
+                <a:ea typeface="Arial"/>
+                <a:cs typeface="Arial"/>
+              </a:defRPr>
+            </a:pPr>
+            <a:r>
+              <a:rPr sz="1575" b="0">
+                <a:solidFill>
+                  <a:srgbClr val="102E38"/>
+                </a:solidFill>
+                <a:latin typeface="Arial"/>
+                <a:ea typeface="Arial"/>
+                <a:cs typeface="Arial"/>
+              </a:rPr>
+              <a:t>2</a:t>
+            </a:r>
+          </a:p>
+        </p:txBody>
+      </p:sp>
+      <p:sp>
+        <p:nvSpPr>
+          <p:cNvPr id="47" name="placement-price-4">
+            <a:extLst xmlns:a="http://schemas.openxmlformats.org/drawingml/2006/main">
+              <a:ext uri="{FF2B5EF4-FFF2-40B4-BE49-F238E27FC236}">
+                <a16:creationId xmlns:a16="http://schemas.microsoft.com/office/drawing/2014/main" id="{8B202565-0E59-4C4B-9153-7B18EE3AD87C}"/>
+              </a:ext>
+            </a:extLst>
+          </p:cNvPr>
+          <p:cNvSpPr>
+            <a:spLocks xmlns:a="http://schemas.openxmlformats.org/drawingml/2006/main" noGrp="1"/>
+          </p:cNvSpPr>
+          <p:nvPr/>
+        </p:nvSpPr>
+        <p:spPr>
+          <a:xfrm xmlns:a="http://schemas.openxmlformats.org/drawingml/2006/main">
+            <a:off x="13239750" y="5133975"/>
             <a:ext cx="1419225" cy="323850"/>
           </a:xfrm>
           <a:prstGeom xmlns:a="http://schemas.openxmlformats.org/drawingml/2006/main" prst="rect">
@@ -2192,6 +2763,7 @@
           <a:lstStyle xmlns:a="http://schemas.openxmlformats.org/drawingml/2006/main"/>
           <a:p xmlns:a="http://schemas.openxmlformats.org/drawingml/2006/main">
             <a:pPr algn="r">
+              <a:buNone/>
               <a:defRPr sz="1725" b="0">
                 <a:solidFill>
                   <a:srgbClr val="102E38"/>
@@ -2210,55 +2782,55 @@
                 <a:ea typeface="Georgia"/>
                 <a:cs typeface="Georgia"/>
               </a:rPr>
-              <a:t>$7,000</a:t>
-            </a:r>
-          </a:p>
-        </p:txBody>
-      </p:sp>
-      <p:sp>
-        <p:nvSpPr>
-          <p:cNvPr id="31" name="row-rule-2">
-            <a:extLst xmlns:a="http://schemas.openxmlformats.org/drawingml/2006/main">
-              <a:ext uri="{FF2B5EF4-FFF2-40B4-BE49-F238E27FC236}">
-                <a16:creationId xmlns:a16="http://schemas.microsoft.com/office/drawing/2014/main" id="{DBC87FF7-969C-4996-B222-265857C40945}"/>
-              </a:ext>
-            </a:extLst>
-          </p:cNvPr>
-          <p:cNvSpPr>
-            <a:spLocks xmlns:a="http://schemas.openxmlformats.org/drawingml/2006/main" noGrp="1"/>
-          </p:cNvSpPr>
-          <p:nvPr/>
-        </p:nvSpPr>
-        <p:spPr>
-          <a:xfrm xmlns:a="http://schemas.openxmlformats.org/drawingml/2006/main">
-            <a:off x="7477125" y="3933825"/>
-            <a:ext cx="7181850" cy="9525"/>
+              <a:t>$5,000</a:t>
+            </a:r>
+          </a:p>
+        </p:txBody>
+      </p:sp>
+      <p:sp>
+        <p:nvSpPr>
+          <p:cNvPr id="49" name="premium-back-highlight">
+            <a:extLst xmlns:a="http://schemas.openxmlformats.org/drawingml/2006/main">
+              <a:ext uri="{FF2B5EF4-FFF2-40B4-BE49-F238E27FC236}">
+                <a16:creationId xmlns:a16="http://schemas.microsoft.com/office/drawing/2014/main" id="{4FE3ECFB-20B0-4E43-AF6F-CCC90F64C6D8}"/>
+              </a:ext>
+            </a:extLst>
+          </p:cNvPr>
+          <p:cNvSpPr>
+            <a:spLocks xmlns:a="http://schemas.openxmlformats.org/drawingml/2006/main" noGrp="1"/>
+          </p:cNvSpPr>
+          <p:nvPr/>
+        </p:nvSpPr>
+        <p:spPr>
+          <a:xfrm xmlns:a="http://schemas.openxmlformats.org/drawingml/2006/main">
+            <a:off x="7362825" y="5600700"/>
+            <a:ext cx="7315200" cy="552450"/>
           </a:xfrm>
           <a:prstGeom xmlns:a="http://schemas.openxmlformats.org/drawingml/2006/main" prst="rect">
             <a:avLst/>
           </a:prstGeom>
           <a:solidFill xmlns:a="http://schemas.openxmlformats.org/drawingml/2006/main">
-            <a:srgbClr val="BCAD86"/>
+            <a:srgbClr val="102E38"/>
           </a:solidFill>
         </p:spPr>
       </p:sp>
       <p:sp>
         <p:nvSpPr>
-          <p:cNvPr id="32" name="placement-number-2">
-            <a:extLst xmlns:a="http://schemas.openxmlformats.org/drawingml/2006/main">
-              <a:ext uri="{FF2B5EF4-FFF2-40B4-BE49-F238E27FC236}">
-                <a16:creationId xmlns:a16="http://schemas.microsoft.com/office/drawing/2014/main" id="{11E37F26-C640-40A5-A56F-EDBACEAAE441}"/>
-              </a:ext>
-            </a:extLst>
-          </p:cNvPr>
-          <p:cNvSpPr>
-            <a:spLocks xmlns:a="http://schemas.openxmlformats.org/drawingml/2006/main" noGrp="1"/>
-          </p:cNvSpPr>
-          <p:nvPr/>
-        </p:nvSpPr>
-        <p:spPr>
-          <a:xfrm xmlns:a="http://schemas.openxmlformats.org/drawingml/2006/main">
-            <a:off x="7496175" y="4057650"/>
+          <p:cNvPr id="50" name="placement-number-5">
+            <a:extLst xmlns:a="http://schemas.openxmlformats.org/drawingml/2006/main">
+              <a:ext uri="{FF2B5EF4-FFF2-40B4-BE49-F238E27FC236}">
+                <a16:creationId xmlns:a16="http://schemas.microsoft.com/office/drawing/2014/main" id="{52163099-08AF-4F74-BF30-29DF39700BCD}"/>
+              </a:ext>
+            </a:extLst>
+          </p:cNvPr>
+          <p:cNvSpPr>
+            <a:spLocks xmlns:a="http://schemas.openxmlformats.org/drawingml/2006/main" noGrp="1"/>
+          </p:cNvSpPr>
+          <p:nvPr/>
+        </p:nvSpPr>
+        <p:spPr>
+          <a:xfrm xmlns:a="http://schemas.openxmlformats.org/drawingml/2006/main">
+            <a:off x="7496175" y="5715000"/>
             <a:ext cx="266700" cy="285750"/>
           </a:xfrm>
           <a:prstGeom xmlns:a="http://schemas.openxmlformats.org/drawingml/2006/main" prst="rect">
@@ -2270,9 +2842,10 @@
           <a:lstStyle xmlns:a="http://schemas.openxmlformats.org/drawingml/2006/main"/>
           <a:p xmlns:a="http://schemas.openxmlformats.org/drawingml/2006/main">
             <a:pPr algn="l">
+              <a:buNone/>
               <a:defRPr sz="1125" b="0">
                 <a:solidFill>
-                  <a:srgbClr val="56686A"/>
+                  <a:srgbClr val="D5B477"/>
                 </a:solidFill>
                 <a:latin typeface="Courier New"/>
                 <a:ea typeface="Courier New"/>
@@ -2282,34 +2855,34 @@
             <a:r>
               <a:rPr sz="1125" b="0">
                 <a:solidFill>
-                  <a:srgbClr val="56686A"/>
+                  <a:srgbClr val="D5B477"/>
                 </a:solidFill>
                 <a:latin typeface="Courier New"/>
                 <a:ea typeface="Courier New"/>
                 <a:cs typeface="Courier New"/>
               </a:rPr>
-              <a:t>3</a:t>
-            </a:r>
-          </a:p>
-        </p:txBody>
-      </p:sp>
-      <p:sp>
-        <p:nvSpPr>
-          <p:cNvPr id="33" name="placement-name-2">
-            <a:extLst xmlns:a="http://schemas.openxmlformats.org/drawingml/2006/main">
-              <a:ext uri="{FF2B5EF4-FFF2-40B4-BE49-F238E27FC236}">
-                <a16:creationId xmlns:a16="http://schemas.microsoft.com/office/drawing/2014/main" id="{FA72C90D-648C-4452-8FC7-D64602600F3E}"/>
-              </a:ext>
-            </a:extLst>
-          </p:cNvPr>
-          <p:cNvSpPr>
-            <a:spLocks xmlns:a="http://schemas.openxmlformats.org/drawingml/2006/main" noGrp="1"/>
-          </p:cNvSpPr>
-          <p:nvPr/>
-        </p:nvSpPr>
-        <p:spPr>
-          <a:xfrm xmlns:a="http://schemas.openxmlformats.org/drawingml/2006/main">
-            <a:off x="7877175" y="4029075"/>
+              <a:t>6</a:t>
+            </a:r>
+          </a:p>
+        </p:txBody>
+      </p:sp>
+      <p:sp>
+        <p:nvSpPr>
+          <p:cNvPr id="51" name="placement-name-5">
+            <a:extLst xmlns:a="http://schemas.openxmlformats.org/drawingml/2006/main">
+              <a:ext uri="{FF2B5EF4-FFF2-40B4-BE49-F238E27FC236}">
+                <a16:creationId xmlns:a16="http://schemas.microsoft.com/office/drawing/2014/main" id="{62D75C8E-0DAF-4352-99CE-C2D9365738BD}"/>
+              </a:ext>
+            </a:extLst>
+          </p:cNvPr>
+          <p:cNvSpPr>
+            <a:spLocks xmlns:a="http://schemas.openxmlformats.org/drawingml/2006/main" noGrp="1"/>
+          </p:cNvSpPr>
+          <p:nvPr/>
+        </p:nvSpPr>
+        <p:spPr>
+          <a:xfrm xmlns:a="http://schemas.openxmlformats.org/drawingml/2006/main">
+            <a:off x="7877175" y="5686425"/>
             <a:ext cx="2667000" cy="323850"/>
           </a:xfrm>
           <a:prstGeom xmlns:a="http://schemas.openxmlformats.org/drawingml/2006/main" prst="rect">
@@ -2321,9 +2894,10 @@
           <a:lstStyle xmlns:a="http://schemas.openxmlformats.org/drawingml/2006/main"/>
           <a:p xmlns:a="http://schemas.openxmlformats.org/drawingml/2006/main">
             <a:pPr algn="l">
-              <a:defRPr sz="1725" b="0">
-                <a:solidFill>
-                  <a:srgbClr val="102E38"/>
+              <a:buNone/>
+              <a:defRPr sz="1725" b="1">
+                <a:solidFill>
+                  <a:srgbClr val="F3EFDF"/>
                 </a:solidFill>
                 <a:latin typeface="Arial"/>
                 <a:ea typeface="Arial"/>
@@ -2331,36 +2905,36 @@
               </a:defRPr>
             </a:pPr>
             <a:r>
-              <a:rPr sz="1725" b="0">
-                <a:solidFill>
-                  <a:srgbClr val="102E38"/>
+              <a:rPr sz="1725" b="1">
+                <a:solidFill>
+                  <a:srgbClr val="F3EFDF"/>
                 </a:solidFill>
                 <a:latin typeface="Arial"/>
                 <a:ea typeface="Arial"/>
                 <a:cs typeface="Arial"/>
               </a:rPr>
-              <a:t>Lower arm</a:t>
-            </a:r>
-          </a:p>
-        </p:txBody>
-      </p:sp>
-      <p:sp>
-        <p:nvSpPr>
-          <p:cNvPr id="34" name="placement-slots-2">
-            <a:extLst xmlns:a="http://schemas.openxmlformats.org/drawingml/2006/main">
-              <a:ext uri="{FF2B5EF4-FFF2-40B4-BE49-F238E27FC236}">
-                <a16:creationId xmlns:a16="http://schemas.microsoft.com/office/drawing/2014/main" id="{3FF2B899-50ED-4566-B3DB-D1F3797FDE64}"/>
-              </a:ext>
-            </a:extLst>
-          </p:cNvPr>
-          <p:cNvSpPr>
-            <a:spLocks xmlns:a="http://schemas.openxmlformats.org/drawingml/2006/main" noGrp="1"/>
-          </p:cNvSpPr>
-          <p:nvPr/>
-        </p:nvSpPr>
-        <p:spPr>
-          <a:xfrm xmlns:a="http://schemas.openxmlformats.org/drawingml/2006/main">
-            <a:off x="10668000" y="4029075"/>
+              <a:t>Large back</a:t>
+            </a:r>
+          </a:p>
+        </p:txBody>
+      </p:sp>
+      <p:sp>
+        <p:nvSpPr>
+          <p:cNvPr id="52" name="placement-slots-5">
+            <a:extLst xmlns:a="http://schemas.openxmlformats.org/drawingml/2006/main">
+              <a:ext uri="{FF2B5EF4-FFF2-40B4-BE49-F238E27FC236}">
+                <a16:creationId xmlns:a16="http://schemas.microsoft.com/office/drawing/2014/main" id="{AD12FD7F-7C5E-4BB7-8E3E-FECAD564DD61}"/>
+              </a:ext>
+            </a:extLst>
+          </p:cNvPr>
+          <p:cNvSpPr>
+            <a:spLocks xmlns:a="http://schemas.openxmlformats.org/drawingml/2006/main" noGrp="1"/>
+          </p:cNvSpPr>
+          <p:nvPr/>
+        </p:nvSpPr>
+        <p:spPr>
+          <a:xfrm xmlns:a="http://schemas.openxmlformats.org/drawingml/2006/main">
+            <a:off x="11239500" y="5686425"/>
             <a:ext cx="685800" cy="323850"/>
           </a:xfrm>
           <a:prstGeom xmlns:a="http://schemas.openxmlformats.org/drawingml/2006/main" prst="rect">
@@ -2372,9 +2946,10 @@
           <a:lstStyle xmlns:a="http://schemas.openxmlformats.org/drawingml/2006/main"/>
           <a:p xmlns:a="http://schemas.openxmlformats.org/drawingml/2006/main">
             <a:pPr algn="ctr">
+              <a:buNone/>
               <a:defRPr sz="1575" b="0">
                 <a:solidFill>
-                  <a:srgbClr val="102E38"/>
+                  <a:srgbClr val="F3EFDF"/>
                 </a:solidFill>
                 <a:latin typeface="Arial"/>
                 <a:ea typeface="Arial"/>
@@ -2384,35 +2959,35 @@
             <a:r>
               <a:rPr sz="1575" b="0">
                 <a:solidFill>
-                  <a:srgbClr val="102E38"/>
+                  <a:srgbClr val="F3EFDF"/>
                 </a:solidFill>
                 <a:latin typeface="Arial"/>
                 <a:ea typeface="Arial"/>
                 <a:cs typeface="Arial"/>
               </a:rPr>
-              <a:t>2</a:t>
-            </a:r>
-          </a:p>
-        </p:txBody>
-      </p:sp>
-      <p:sp>
-        <p:nvSpPr>
-          <p:cNvPr id="35" name="placement-price-2">
-            <a:extLst xmlns:a="http://schemas.openxmlformats.org/drawingml/2006/main">
-              <a:ext uri="{FF2B5EF4-FFF2-40B4-BE49-F238E27FC236}">
-                <a16:creationId xmlns:a16="http://schemas.microsoft.com/office/drawing/2014/main" id="{7159A623-F2C1-4E10-A16B-4D2718F24CCE}"/>
-              </a:ext>
-            </a:extLst>
-          </p:cNvPr>
-          <p:cNvSpPr>
-            <a:spLocks xmlns:a="http://schemas.openxmlformats.org/drawingml/2006/main" noGrp="1"/>
-          </p:cNvSpPr>
-          <p:nvPr/>
-        </p:nvSpPr>
-        <p:spPr>
-          <a:xfrm xmlns:a="http://schemas.openxmlformats.org/drawingml/2006/main">
-            <a:off x="11620500" y="4029075"/>
-            <a:ext cx="1314450" cy="323850"/>
+              <a:t>1</a:t>
+            </a:r>
+          </a:p>
+        </p:txBody>
+      </p:sp>
+      <p:sp>
+        <p:nvSpPr>
+          <p:cNvPr id="53" name="placement-price-5">
+            <a:extLst xmlns:a="http://schemas.openxmlformats.org/drawingml/2006/main">
+              <a:ext uri="{FF2B5EF4-FFF2-40B4-BE49-F238E27FC236}">
+                <a16:creationId xmlns:a16="http://schemas.microsoft.com/office/drawing/2014/main" id="{98E0FC70-8B1E-46E1-B564-72CB28AE8D1D}"/>
+              </a:ext>
+            </a:extLst>
+          </p:cNvPr>
+          <p:cNvSpPr>
+            <a:spLocks xmlns:a="http://schemas.openxmlformats.org/drawingml/2006/main" noGrp="1"/>
+          </p:cNvSpPr>
+          <p:nvPr/>
+        </p:nvSpPr>
+        <p:spPr>
+          <a:xfrm xmlns:a="http://schemas.openxmlformats.org/drawingml/2006/main">
+            <a:off x="13239750" y="5686425"/>
+            <a:ext cx="1419225" cy="323850"/>
           </a:xfrm>
           <a:prstGeom xmlns:a="http://schemas.openxmlformats.org/drawingml/2006/main" prst="rect">
             <a:avLst/>
@@ -2423,9 +2998,10 @@
           <a:lstStyle xmlns:a="http://schemas.openxmlformats.org/drawingml/2006/main"/>
           <a:p xmlns:a="http://schemas.openxmlformats.org/drawingml/2006/main">
             <a:pPr algn="r">
+              <a:buNone/>
               <a:defRPr sz="1725" b="0">
                 <a:solidFill>
-                  <a:srgbClr val="102E38"/>
+                  <a:srgbClr val="F3EFDF"/>
                 </a:solidFill>
                 <a:latin typeface="Georgia"/>
                 <a:ea typeface="Georgia"/>
@@ -2435,113 +3011,35 @@
             <a:r>
               <a:rPr sz="1725" b="0">
                 <a:solidFill>
-                  <a:srgbClr val="102E38"/>
+                  <a:srgbClr val="F3EFDF"/>
                 </a:solidFill>
                 <a:latin typeface="Georgia"/>
                 <a:ea typeface="Georgia"/>
                 <a:cs typeface="Georgia"/>
               </a:rPr>
-              <a:t>$3,000</a:t>
-            </a:r>
-          </a:p>
-        </p:txBody>
-      </p:sp>
-      <p:sp>
-        <p:nvSpPr>
-          <p:cNvPr id="36" name="placement-revenue-2">
-            <a:extLst xmlns:a="http://schemas.openxmlformats.org/drawingml/2006/main">
-              <a:ext uri="{FF2B5EF4-FFF2-40B4-BE49-F238E27FC236}">
-                <a16:creationId xmlns:a16="http://schemas.microsoft.com/office/drawing/2014/main" id="{6A6770F9-70CC-4F3B-903C-DD79DEDA0FCD}"/>
-              </a:ext>
-            </a:extLst>
-          </p:cNvPr>
-          <p:cNvSpPr>
-            <a:spLocks xmlns:a="http://schemas.openxmlformats.org/drawingml/2006/main" noGrp="1"/>
-          </p:cNvSpPr>
-          <p:nvPr/>
-        </p:nvSpPr>
-        <p:spPr>
-          <a:xfrm xmlns:a="http://schemas.openxmlformats.org/drawingml/2006/main">
-            <a:off x="13239750" y="4029075"/>
-            <a:ext cx="1419225" cy="323850"/>
-          </a:xfrm>
-          <a:prstGeom xmlns:a="http://schemas.openxmlformats.org/drawingml/2006/main" prst="rect">
-            <a:avLst/>
-          </a:prstGeom>
-        </p:spPr>
-        <p:txBody>
-          <a:bodyPr xmlns:a="http://schemas.openxmlformats.org/drawingml/2006/main" wrap="none" lIns="0" tIns="0" rIns="0" bIns="0" anchor="ctr"/>
-          <a:lstStyle xmlns:a="http://schemas.openxmlformats.org/drawingml/2006/main"/>
-          <a:p xmlns:a="http://schemas.openxmlformats.org/drawingml/2006/main">
-            <a:pPr algn="r">
-              <a:defRPr sz="1725" b="0">
-                <a:solidFill>
-                  <a:srgbClr val="102E38"/>
-                </a:solidFill>
-                <a:latin typeface="Georgia"/>
-                <a:ea typeface="Georgia"/>
-                <a:cs typeface="Georgia"/>
-              </a:defRPr>
-            </a:pPr>
-            <a:r>
-              <a:rPr sz="1725" b="0">
-                <a:solidFill>
-                  <a:srgbClr val="102E38"/>
-                </a:solidFill>
-                <a:latin typeface="Georgia"/>
-                <a:ea typeface="Georgia"/>
-                <a:cs typeface="Georgia"/>
-              </a:rPr>
-              <a:t>$6,000</a:t>
-            </a:r>
-          </a:p>
-        </p:txBody>
-      </p:sp>
-      <p:sp>
-        <p:nvSpPr>
-          <p:cNvPr id="37" name="row-rule-3">
-            <a:extLst xmlns:a="http://schemas.openxmlformats.org/drawingml/2006/main">
-              <a:ext uri="{FF2B5EF4-FFF2-40B4-BE49-F238E27FC236}">
-                <a16:creationId xmlns:a16="http://schemas.microsoft.com/office/drawing/2014/main" id="{FE927755-550B-41E8-BE68-B34C65B92CE1}"/>
-              </a:ext>
-            </a:extLst>
-          </p:cNvPr>
-          <p:cNvSpPr>
-            <a:spLocks xmlns:a="http://schemas.openxmlformats.org/drawingml/2006/main" noGrp="1"/>
-          </p:cNvSpPr>
-          <p:nvPr/>
-        </p:nvSpPr>
-        <p:spPr>
-          <a:xfrm xmlns:a="http://schemas.openxmlformats.org/drawingml/2006/main">
-            <a:off x="7477125" y="4486275"/>
-            <a:ext cx="7181850" cy="9525"/>
-          </a:xfrm>
-          <a:prstGeom xmlns:a="http://schemas.openxmlformats.org/drawingml/2006/main" prst="rect">
-            <a:avLst/>
-          </a:prstGeom>
-          <a:solidFill xmlns:a="http://schemas.openxmlformats.org/drawingml/2006/main">
-            <a:srgbClr val="BCAD86"/>
-          </a:solidFill>
-        </p:spPr>
-      </p:sp>
-      <p:sp>
-        <p:nvSpPr>
-          <p:cNvPr id="38" name="placement-number-3">
-            <a:extLst xmlns:a="http://schemas.openxmlformats.org/drawingml/2006/main">
-              <a:ext uri="{FF2B5EF4-FFF2-40B4-BE49-F238E27FC236}">
-                <a16:creationId xmlns:a16="http://schemas.microsoft.com/office/drawing/2014/main" id="{3238E5EB-FA09-4B8C-BCE3-4497DA39F0F8}"/>
-              </a:ext>
-            </a:extLst>
-          </p:cNvPr>
-          <p:cNvSpPr>
-            <a:spLocks xmlns:a="http://schemas.openxmlformats.org/drawingml/2006/main" noGrp="1"/>
-          </p:cNvSpPr>
-          <p:nvPr/>
-        </p:nvSpPr>
-        <p:spPr>
-          <a:xfrm xmlns:a="http://schemas.openxmlformats.org/drawingml/2006/main">
-            <a:off x="7496175" y="4610100"/>
-            <a:ext cx="266700" cy="285750"/>
+              <a:t>$21,000</a:t>
+            </a:r>
+          </a:p>
+        </p:txBody>
+      </p:sp>
+      <p:sp>
+        <p:nvSpPr>
+          <p:cNvPr id="59" name="terms">
+            <a:extLst xmlns:a="http://schemas.openxmlformats.org/drawingml/2006/main">
+              <a:ext uri="{FF2B5EF4-FFF2-40B4-BE49-F238E27FC236}">
+                <a16:creationId xmlns:a16="http://schemas.microsoft.com/office/drawing/2014/main" id="{76968606-EB12-40C1-99BC-C774E53E1E4D}"/>
+              </a:ext>
+            </a:extLst>
+          </p:cNvPr>
+          <p:cNvSpPr>
+            <a:spLocks xmlns:a="http://schemas.openxmlformats.org/drawingml/2006/main" noGrp="1"/>
+          </p:cNvSpPr>
+          <p:nvPr/>
+        </p:nvSpPr>
+        <p:spPr>
+          <a:xfrm xmlns:a="http://schemas.openxmlformats.org/drawingml/2006/main">
+            <a:off x="7477125" y="6858000"/>
+            <a:ext cx="7181850" cy="238125"/>
           </a:xfrm>
           <a:prstGeom xmlns:a="http://schemas.openxmlformats.org/drawingml/2006/main" prst="rect">
             <a:avLst/>
@@ -2552,60 +3050,10 @@
           <a:lstStyle xmlns:a="http://schemas.openxmlformats.org/drawingml/2006/main"/>
           <a:p xmlns:a="http://schemas.openxmlformats.org/drawingml/2006/main">
             <a:pPr algn="l">
-              <a:defRPr sz="1125" b="0">
+              <a:buNone/>
+              <a:defRPr sz="1200" b="0">
                 <a:solidFill>
                   <a:srgbClr val="56686A"/>
-                </a:solidFill>
-                <a:latin typeface="Courier New"/>
-                <a:ea typeface="Courier New"/>
-                <a:cs typeface="Courier New"/>
-              </a:defRPr>
-            </a:pPr>
-            <a:r>
-              <a:rPr sz="1125" b="0">
-                <a:solidFill>
-                  <a:srgbClr val="56686A"/>
-                </a:solidFill>
-                <a:latin typeface="Courier New"/>
-                <a:ea typeface="Courier New"/>
-                <a:cs typeface="Courier New"/>
-              </a:rPr>
-              <a:t>4</a:t>
-            </a:r>
-          </a:p>
-        </p:txBody>
-      </p:sp>
-      <p:sp>
-        <p:nvSpPr>
-          <p:cNvPr id="39" name="placement-name-3">
-            <a:extLst xmlns:a="http://schemas.openxmlformats.org/drawingml/2006/main">
-              <a:ext uri="{FF2B5EF4-FFF2-40B4-BE49-F238E27FC236}">
-                <a16:creationId xmlns:a16="http://schemas.microsoft.com/office/drawing/2014/main" id="{37624AFC-AB39-4E42-BCA1-7448D02FAC03}"/>
-              </a:ext>
-            </a:extLst>
-          </p:cNvPr>
-          <p:cNvSpPr>
-            <a:spLocks xmlns:a="http://schemas.openxmlformats.org/drawingml/2006/main" noGrp="1"/>
-          </p:cNvSpPr>
-          <p:nvPr/>
-        </p:nvSpPr>
-        <p:spPr>
-          <a:xfrm xmlns:a="http://schemas.openxmlformats.org/drawingml/2006/main">
-            <a:off x="7877175" y="4581525"/>
-            <a:ext cx="2667000" cy="323850"/>
-          </a:xfrm>
-          <a:prstGeom xmlns:a="http://schemas.openxmlformats.org/drawingml/2006/main" prst="rect">
-            <a:avLst/>
-          </a:prstGeom>
-        </p:spPr>
-        <p:txBody>
-          <a:bodyPr xmlns:a="http://schemas.openxmlformats.org/drawingml/2006/main" wrap="none" lIns="0" tIns="0" rIns="0" bIns="0" anchor="ctr"/>
-          <a:lstStyle xmlns:a="http://schemas.openxmlformats.org/drawingml/2006/main"/>
-          <a:p xmlns:a="http://schemas.openxmlformats.org/drawingml/2006/main">
-            <a:pPr algn="l">
-              <a:defRPr sz="1725" b="0">
-                <a:solidFill>
-                  <a:srgbClr val="102E38"/>
                 </a:solidFill>
                 <a:latin typeface="Arial"/>
                 <a:ea typeface="Arial"/>
@@ -2613,217 +3061,37 @@
               </a:defRPr>
             </a:pPr>
             <a:r>
-              <a:rPr sz="1725" b="0">
-                <a:solidFill>
-                  <a:srgbClr val="102E38"/>
+              <a:rPr sz="1200" b="0">
+                <a:solidFill>
+                  <a:srgbClr val="56686A"/>
                 </a:solidFill>
                 <a:latin typeface="Arial"/>
                 <a:ea typeface="Arial"/>
                 <a:cs typeface="Arial"/>
               </a:rPr>
-              <a:t>Left chest</a:t>
-            </a:r>
-          </a:p>
-        </p:txBody>
-      </p:sp>
-      <p:sp>
-        <p:nvSpPr>
-          <p:cNvPr id="40" name="placement-slots-3">
-            <a:extLst xmlns:a="http://schemas.openxmlformats.org/drawingml/2006/main">
-              <a:ext uri="{FF2B5EF4-FFF2-40B4-BE49-F238E27FC236}">
-                <a16:creationId xmlns:a16="http://schemas.microsoft.com/office/drawing/2014/main" id="{C3DF1D47-4B49-4F38-BD74-4F1D56E3DA6A}"/>
-              </a:ext>
-            </a:extLst>
-          </p:cNvPr>
-          <p:cNvSpPr>
-            <a:spLocks xmlns:a="http://schemas.openxmlformats.org/drawingml/2006/main" noGrp="1"/>
-          </p:cNvSpPr>
-          <p:nvPr/>
-        </p:nvSpPr>
-        <p:spPr>
-          <a:xfrm xmlns:a="http://schemas.openxmlformats.org/drawingml/2006/main">
-            <a:off x="10668000" y="4581525"/>
-            <a:ext cx="685800" cy="323850"/>
-          </a:xfrm>
-          <a:prstGeom xmlns:a="http://schemas.openxmlformats.org/drawingml/2006/main" prst="rect">
-            <a:avLst/>
-          </a:prstGeom>
-        </p:spPr>
-        <p:txBody>
-          <a:bodyPr xmlns:a="http://schemas.openxmlformats.org/drawingml/2006/main" wrap="none" lIns="0" tIns="0" rIns="0" bIns="0" anchor="ctr"/>
-          <a:lstStyle xmlns:a="http://schemas.openxmlformats.org/drawingml/2006/main"/>
-          <a:p xmlns:a="http://schemas.openxmlformats.org/drawingml/2006/main">
-            <a:pPr algn="ctr">
-              <a:defRPr sz="1575" b="0">
-                <a:solidFill>
-                  <a:srgbClr val="102E38"/>
-                </a:solidFill>
-                <a:latin typeface="Arial"/>
-                <a:ea typeface="Arial"/>
-                <a:cs typeface="Arial"/>
-              </a:defRPr>
-            </a:pPr>
-            <a:r>
-              <a:rPr sz="1575" b="0">
-                <a:solidFill>
-                  <a:srgbClr val="102E38"/>
-                </a:solidFill>
-                <a:latin typeface="Arial"/>
-                <a:ea typeface="Arial"/>
-                <a:cs typeface="Arial"/>
-              </a:rPr>
-              <a:t>1</a:t>
-            </a:r>
-          </a:p>
-        </p:txBody>
-      </p:sp>
-      <p:sp>
-        <p:nvSpPr>
-          <p:cNvPr id="41" name="placement-price-3">
-            <a:extLst xmlns:a="http://schemas.openxmlformats.org/drawingml/2006/main">
-              <a:ext uri="{FF2B5EF4-FFF2-40B4-BE49-F238E27FC236}">
-                <a16:creationId xmlns:a16="http://schemas.microsoft.com/office/drawing/2014/main" id="{ABC306AF-26EE-4EA2-BB3D-C5C1B09C7515}"/>
-              </a:ext>
-            </a:extLst>
-          </p:cNvPr>
-          <p:cNvSpPr>
-            <a:spLocks xmlns:a="http://schemas.openxmlformats.org/drawingml/2006/main" noGrp="1"/>
-          </p:cNvSpPr>
-          <p:nvPr/>
-        </p:nvSpPr>
-        <p:spPr>
-          <a:xfrm xmlns:a="http://schemas.openxmlformats.org/drawingml/2006/main">
-            <a:off x="11620500" y="4581525"/>
-            <a:ext cx="1314450" cy="323850"/>
-          </a:xfrm>
-          <a:prstGeom xmlns:a="http://schemas.openxmlformats.org/drawingml/2006/main" prst="rect">
-            <a:avLst/>
-          </a:prstGeom>
-        </p:spPr>
-        <p:txBody>
-          <a:bodyPr xmlns:a="http://schemas.openxmlformats.org/drawingml/2006/main" wrap="none" lIns="0" tIns="0" rIns="0" bIns="0" anchor="ctr"/>
-          <a:lstStyle xmlns:a="http://schemas.openxmlformats.org/drawingml/2006/main"/>
-          <a:p xmlns:a="http://schemas.openxmlformats.org/drawingml/2006/main">
-            <a:pPr algn="r">
-              <a:defRPr sz="1725" b="0">
-                <a:solidFill>
-                  <a:srgbClr val="102E38"/>
-                </a:solidFill>
-                <a:latin typeface="Georgia"/>
-                <a:ea typeface="Georgia"/>
-                <a:cs typeface="Georgia"/>
-              </a:defRPr>
-            </a:pPr>
-            <a:r>
-              <a:rPr sz="1725" b="0">
-                <a:solidFill>
-                  <a:srgbClr val="102E38"/>
-                </a:solidFill>
-                <a:latin typeface="Georgia"/>
-                <a:ea typeface="Georgia"/>
-                <a:cs typeface="Georgia"/>
-              </a:rPr>
-              <a:t>$7,000</a:t>
-            </a:r>
-          </a:p>
-        </p:txBody>
-      </p:sp>
-      <p:sp>
-        <p:nvSpPr>
-          <p:cNvPr id="42" name="placement-revenue-3">
-            <a:extLst xmlns:a="http://schemas.openxmlformats.org/drawingml/2006/main">
-              <a:ext uri="{FF2B5EF4-FFF2-40B4-BE49-F238E27FC236}">
-                <a16:creationId xmlns:a16="http://schemas.microsoft.com/office/drawing/2014/main" id="{1B6D6879-DE49-4E4F-9249-1EEA8EAE2B05}"/>
-              </a:ext>
-            </a:extLst>
-          </p:cNvPr>
-          <p:cNvSpPr>
-            <a:spLocks xmlns:a="http://schemas.openxmlformats.org/drawingml/2006/main" noGrp="1"/>
-          </p:cNvSpPr>
-          <p:nvPr/>
-        </p:nvSpPr>
-        <p:spPr>
-          <a:xfrm xmlns:a="http://schemas.openxmlformats.org/drawingml/2006/main">
-            <a:off x="13239750" y="4581525"/>
-            <a:ext cx="1419225" cy="323850"/>
-          </a:xfrm>
-          <a:prstGeom xmlns:a="http://schemas.openxmlformats.org/drawingml/2006/main" prst="rect">
-            <a:avLst/>
-          </a:prstGeom>
-        </p:spPr>
-        <p:txBody>
-          <a:bodyPr xmlns:a="http://schemas.openxmlformats.org/drawingml/2006/main" wrap="none" lIns="0" tIns="0" rIns="0" bIns="0" anchor="ctr"/>
-          <a:lstStyle xmlns:a="http://schemas.openxmlformats.org/drawingml/2006/main"/>
-          <a:p xmlns:a="http://schemas.openxmlformats.org/drawingml/2006/main">
-            <a:pPr algn="r">
-              <a:defRPr sz="1725" b="0">
-                <a:solidFill>
-                  <a:srgbClr val="102E38"/>
-                </a:solidFill>
-                <a:latin typeface="Georgia"/>
-                <a:ea typeface="Georgia"/>
-                <a:cs typeface="Georgia"/>
-              </a:defRPr>
-            </a:pPr>
-            <a:r>
-              <a:rPr sz="1725" b="0">
-                <a:solidFill>
-                  <a:srgbClr val="102E38"/>
-                </a:solidFill>
-                <a:latin typeface="Georgia"/>
-                <a:ea typeface="Georgia"/>
-                <a:cs typeface="Georgia"/>
-              </a:rPr>
-              <a:t>$7,000</a:t>
-            </a:r>
-          </a:p>
-        </p:txBody>
-      </p:sp>
-      <p:sp>
-        <p:nvSpPr>
-          <p:cNvPr id="43" name="row-rule-4">
-            <a:extLst xmlns:a="http://schemas.openxmlformats.org/drawingml/2006/main">
-              <a:ext uri="{FF2B5EF4-FFF2-40B4-BE49-F238E27FC236}">
-                <a16:creationId xmlns:a16="http://schemas.microsoft.com/office/drawing/2014/main" id="{03F8C9ED-9BFA-4266-AE7A-F5691A702EFF}"/>
-              </a:ext>
-            </a:extLst>
-          </p:cNvPr>
-          <p:cNvSpPr>
-            <a:spLocks xmlns:a="http://schemas.openxmlformats.org/drawingml/2006/main" noGrp="1"/>
-          </p:cNvSpPr>
-          <p:nvPr/>
-        </p:nvSpPr>
-        <p:spPr>
-          <a:xfrm xmlns:a="http://schemas.openxmlformats.org/drawingml/2006/main">
-            <a:off x="7477125" y="5038725"/>
-            <a:ext cx="7181850" cy="9525"/>
-          </a:xfrm>
-          <a:prstGeom xmlns:a="http://schemas.openxmlformats.org/drawingml/2006/main" prst="rect">
-            <a:avLst/>
-          </a:prstGeom>
-          <a:solidFill xmlns:a="http://schemas.openxmlformats.org/drawingml/2006/main">
-            <a:srgbClr val="BCAD86"/>
-          </a:solidFill>
-        </p:spPr>
-      </p:sp>
-      <p:sp>
-        <p:nvSpPr>
-          <p:cNvPr id="44" name="placement-number-4">
-            <a:extLst xmlns:a="http://schemas.openxmlformats.org/drawingml/2006/main">
-              <a:ext uri="{FF2B5EF4-FFF2-40B4-BE49-F238E27FC236}">
-                <a16:creationId xmlns:a16="http://schemas.microsoft.com/office/drawing/2014/main" id="{73C457EC-9489-4AC6-BD00-891DBAB1A384}"/>
-              </a:ext>
-            </a:extLst>
-          </p:cNvPr>
-          <p:cNvSpPr>
-            <a:spLocks xmlns:a="http://schemas.openxmlformats.org/drawingml/2006/main" noGrp="1"/>
-          </p:cNvSpPr>
-          <p:nvPr/>
-        </p:nvSpPr>
-        <p:spPr>
-          <a:xfrm xmlns:a="http://schemas.openxmlformats.org/drawingml/2006/main">
-            <a:off x="7496175" y="5162550"/>
-            <a:ext cx="266700" cy="285750"/>
+              <a:t>Each price covers all parkas. Expedition tickets are separate.</a:t>
+            </a:r>
+          </a:p>
+        </p:txBody>
+      </p:sp>
+      <p:sp>
+        <p:nvSpPr>
+          <p:cNvPr id="60" name="terms-second">
+            <a:extLst xmlns:a="http://schemas.openxmlformats.org/drawingml/2006/main">
+              <a:ext uri="{FF2B5EF4-FFF2-40B4-BE49-F238E27FC236}">
+                <a16:creationId xmlns:a16="http://schemas.microsoft.com/office/drawing/2014/main" id="{E6F16F5F-0AC2-4955-8473-869570175677}"/>
+              </a:ext>
+            </a:extLst>
+          </p:cNvPr>
+          <p:cNvSpPr>
+            <a:spLocks xmlns:a="http://schemas.openxmlformats.org/drawingml/2006/main" noGrp="1"/>
+          </p:cNvSpPr>
+          <p:nvPr/>
+        </p:nvSpPr>
+        <p:spPr>
+          <a:xfrm xmlns:a="http://schemas.openxmlformats.org/drawingml/2006/main">
+            <a:off x="7477125" y="7181850"/>
+            <a:ext cx="7181850" cy="238125"/>
           </a:xfrm>
           <a:prstGeom xmlns:a="http://schemas.openxmlformats.org/drawingml/2006/main" prst="rect">
             <a:avLst/>
@@ -2834,774 +3102,7 @@
           <a:lstStyle xmlns:a="http://schemas.openxmlformats.org/drawingml/2006/main"/>
           <a:p xmlns:a="http://schemas.openxmlformats.org/drawingml/2006/main">
             <a:pPr algn="l">
-              <a:defRPr sz="1125" b="0">
-                <a:solidFill>
-                  <a:srgbClr val="56686A"/>
-                </a:solidFill>
-                <a:latin typeface="Courier New"/>
-                <a:ea typeface="Courier New"/>
-                <a:cs typeface="Courier New"/>
-              </a:defRPr>
-            </a:pPr>
-            <a:r>
-              <a:rPr sz="1125" b="0">
-                <a:solidFill>
-                  <a:srgbClr val="56686A"/>
-                </a:solidFill>
-                <a:latin typeface="Courier New"/>
-                <a:ea typeface="Courier New"/>
-                <a:cs typeface="Courier New"/>
-              </a:rPr>
-              <a:t>5</a:t>
-            </a:r>
-          </a:p>
-        </p:txBody>
-      </p:sp>
-      <p:sp>
-        <p:nvSpPr>
-          <p:cNvPr id="45" name="placement-name-4">
-            <a:extLst xmlns:a="http://schemas.openxmlformats.org/drawingml/2006/main">
-              <a:ext uri="{FF2B5EF4-FFF2-40B4-BE49-F238E27FC236}">
-                <a16:creationId xmlns:a16="http://schemas.microsoft.com/office/drawing/2014/main" id="{16449C19-3B89-4CA3-8CCB-71E4C462DB34}"/>
-              </a:ext>
-            </a:extLst>
-          </p:cNvPr>
-          <p:cNvSpPr>
-            <a:spLocks xmlns:a="http://schemas.openxmlformats.org/drawingml/2006/main" noGrp="1"/>
-          </p:cNvSpPr>
-          <p:nvPr/>
-        </p:nvSpPr>
-        <p:spPr>
-          <a:xfrm xmlns:a="http://schemas.openxmlformats.org/drawingml/2006/main">
-            <a:off x="7877175" y="5133975"/>
-            <a:ext cx="2667000" cy="323850"/>
-          </a:xfrm>
-          <a:prstGeom xmlns:a="http://schemas.openxmlformats.org/drawingml/2006/main" prst="rect">
-            <a:avLst/>
-          </a:prstGeom>
-        </p:spPr>
-        <p:txBody>
-          <a:bodyPr xmlns:a="http://schemas.openxmlformats.org/drawingml/2006/main" wrap="none" lIns="0" tIns="0" rIns="0" bIns="0" anchor="ctr"/>
-          <a:lstStyle xmlns:a="http://schemas.openxmlformats.org/drawingml/2006/main"/>
-          <a:p xmlns:a="http://schemas.openxmlformats.org/drawingml/2006/main">
-            <a:pPr algn="l">
-              <a:defRPr sz="1725" b="0">
-                <a:solidFill>
-                  <a:srgbClr val="102E38"/>
-                </a:solidFill>
-                <a:latin typeface="Arial"/>
-                <a:ea typeface="Arial"/>
-                <a:cs typeface="Arial"/>
-              </a:defRPr>
-            </a:pPr>
-            <a:r>
-              <a:rPr sz="1725" b="0">
-                <a:solidFill>
-                  <a:srgbClr val="102E38"/>
-                </a:solidFill>
-                <a:latin typeface="Arial"/>
-                <a:ea typeface="Arial"/>
-                <a:cs typeface="Arial"/>
-              </a:rPr>
-              <a:t>Right front</a:t>
-            </a:r>
-          </a:p>
-        </p:txBody>
-      </p:sp>
-      <p:sp>
-        <p:nvSpPr>
-          <p:cNvPr id="46" name="placement-slots-4">
-            <a:extLst xmlns:a="http://schemas.openxmlformats.org/drawingml/2006/main">
-              <a:ext uri="{FF2B5EF4-FFF2-40B4-BE49-F238E27FC236}">
-                <a16:creationId xmlns:a16="http://schemas.microsoft.com/office/drawing/2014/main" id="{E71A654E-B4F2-40B2-9B65-8293B21C0B6C}"/>
-              </a:ext>
-            </a:extLst>
-          </p:cNvPr>
-          <p:cNvSpPr>
-            <a:spLocks xmlns:a="http://schemas.openxmlformats.org/drawingml/2006/main" noGrp="1"/>
-          </p:cNvSpPr>
-          <p:nvPr/>
-        </p:nvSpPr>
-        <p:spPr>
-          <a:xfrm xmlns:a="http://schemas.openxmlformats.org/drawingml/2006/main">
-            <a:off x="10668000" y="5133975"/>
-            <a:ext cx="685800" cy="323850"/>
-          </a:xfrm>
-          <a:prstGeom xmlns:a="http://schemas.openxmlformats.org/drawingml/2006/main" prst="rect">
-            <a:avLst/>
-          </a:prstGeom>
-        </p:spPr>
-        <p:txBody>
-          <a:bodyPr xmlns:a="http://schemas.openxmlformats.org/drawingml/2006/main" wrap="none" lIns="0" tIns="0" rIns="0" bIns="0" anchor="ctr"/>
-          <a:lstStyle xmlns:a="http://schemas.openxmlformats.org/drawingml/2006/main"/>
-          <a:p xmlns:a="http://schemas.openxmlformats.org/drawingml/2006/main">
-            <a:pPr algn="ctr">
-              <a:defRPr sz="1575" b="0">
-                <a:solidFill>
-                  <a:srgbClr val="102E38"/>
-                </a:solidFill>
-                <a:latin typeface="Arial"/>
-                <a:ea typeface="Arial"/>
-                <a:cs typeface="Arial"/>
-              </a:defRPr>
-            </a:pPr>
-            <a:r>
-              <a:rPr sz="1575" b="0">
-                <a:solidFill>
-                  <a:srgbClr val="102E38"/>
-                </a:solidFill>
-                <a:latin typeface="Arial"/>
-                <a:ea typeface="Arial"/>
-                <a:cs typeface="Arial"/>
-              </a:rPr>
-              <a:t>2</a:t>
-            </a:r>
-          </a:p>
-        </p:txBody>
-      </p:sp>
-      <p:sp>
-        <p:nvSpPr>
-          <p:cNvPr id="47" name="placement-price-4">
-            <a:extLst xmlns:a="http://schemas.openxmlformats.org/drawingml/2006/main">
-              <a:ext uri="{FF2B5EF4-FFF2-40B4-BE49-F238E27FC236}">
-                <a16:creationId xmlns:a16="http://schemas.microsoft.com/office/drawing/2014/main" id="{8B202565-0E59-4C4B-9153-7B18EE3AD87C}"/>
-              </a:ext>
-            </a:extLst>
-          </p:cNvPr>
-          <p:cNvSpPr>
-            <a:spLocks xmlns:a="http://schemas.openxmlformats.org/drawingml/2006/main" noGrp="1"/>
-          </p:cNvSpPr>
-          <p:nvPr/>
-        </p:nvSpPr>
-        <p:spPr>
-          <a:xfrm xmlns:a="http://schemas.openxmlformats.org/drawingml/2006/main">
-            <a:off x="11620500" y="5133975"/>
-            <a:ext cx="1314450" cy="323850"/>
-          </a:xfrm>
-          <a:prstGeom xmlns:a="http://schemas.openxmlformats.org/drawingml/2006/main" prst="rect">
-            <a:avLst/>
-          </a:prstGeom>
-        </p:spPr>
-        <p:txBody>
-          <a:bodyPr xmlns:a="http://schemas.openxmlformats.org/drawingml/2006/main" wrap="none" lIns="0" tIns="0" rIns="0" bIns="0" anchor="ctr"/>
-          <a:lstStyle xmlns:a="http://schemas.openxmlformats.org/drawingml/2006/main"/>
-          <a:p xmlns:a="http://schemas.openxmlformats.org/drawingml/2006/main">
-            <a:pPr algn="r">
-              <a:defRPr sz="1725" b="0">
-                <a:solidFill>
-                  <a:srgbClr val="102E38"/>
-                </a:solidFill>
-                <a:latin typeface="Georgia"/>
-                <a:ea typeface="Georgia"/>
-                <a:cs typeface="Georgia"/>
-              </a:defRPr>
-            </a:pPr>
-            <a:r>
-              <a:rPr sz="1725" b="0">
-                <a:solidFill>
-                  <a:srgbClr val="102E38"/>
-                </a:solidFill>
-                <a:latin typeface="Georgia"/>
-                <a:ea typeface="Georgia"/>
-                <a:cs typeface="Georgia"/>
-              </a:rPr>
-              <a:t>$5,000</a:t>
-            </a:r>
-          </a:p>
-        </p:txBody>
-      </p:sp>
-      <p:sp>
-        <p:nvSpPr>
-          <p:cNvPr id="48" name="placement-revenue-4">
-            <a:extLst xmlns:a="http://schemas.openxmlformats.org/drawingml/2006/main">
-              <a:ext uri="{FF2B5EF4-FFF2-40B4-BE49-F238E27FC236}">
-                <a16:creationId xmlns:a16="http://schemas.microsoft.com/office/drawing/2014/main" id="{EBDAA938-741B-4188-A05A-E97F68A794CA}"/>
-              </a:ext>
-            </a:extLst>
-          </p:cNvPr>
-          <p:cNvSpPr>
-            <a:spLocks xmlns:a="http://schemas.openxmlformats.org/drawingml/2006/main" noGrp="1"/>
-          </p:cNvSpPr>
-          <p:nvPr/>
-        </p:nvSpPr>
-        <p:spPr>
-          <a:xfrm xmlns:a="http://schemas.openxmlformats.org/drawingml/2006/main">
-            <a:off x="13239750" y="5133975"/>
-            <a:ext cx="1419225" cy="323850"/>
-          </a:xfrm>
-          <a:prstGeom xmlns:a="http://schemas.openxmlformats.org/drawingml/2006/main" prst="rect">
-            <a:avLst/>
-          </a:prstGeom>
-        </p:spPr>
-        <p:txBody>
-          <a:bodyPr xmlns:a="http://schemas.openxmlformats.org/drawingml/2006/main" wrap="none" lIns="0" tIns="0" rIns="0" bIns="0" anchor="ctr"/>
-          <a:lstStyle xmlns:a="http://schemas.openxmlformats.org/drawingml/2006/main"/>
-          <a:p xmlns:a="http://schemas.openxmlformats.org/drawingml/2006/main">
-            <a:pPr algn="r">
-              <a:defRPr sz="1725" b="0">
-                <a:solidFill>
-                  <a:srgbClr val="102E38"/>
-                </a:solidFill>
-                <a:latin typeface="Georgia"/>
-                <a:ea typeface="Georgia"/>
-                <a:cs typeface="Georgia"/>
-              </a:defRPr>
-            </a:pPr>
-            <a:r>
-              <a:rPr sz="1725" b="0">
-                <a:solidFill>
-                  <a:srgbClr val="102E38"/>
-                </a:solidFill>
-                <a:latin typeface="Georgia"/>
-                <a:ea typeface="Georgia"/>
-                <a:cs typeface="Georgia"/>
-              </a:rPr>
-              <a:t>$10,000</a:t>
-            </a:r>
-          </a:p>
-        </p:txBody>
-      </p:sp>
-      <p:sp>
-        <p:nvSpPr>
-          <p:cNvPr id="49" name="premium-back-highlight">
-            <a:extLst xmlns:a="http://schemas.openxmlformats.org/drawingml/2006/main">
-              <a:ext uri="{FF2B5EF4-FFF2-40B4-BE49-F238E27FC236}">
-                <a16:creationId xmlns:a16="http://schemas.microsoft.com/office/drawing/2014/main" id="{4FE3ECFB-20B0-4E43-AF6F-CCC90F64C6D8}"/>
-              </a:ext>
-            </a:extLst>
-          </p:cNvPr>
-          <p:cNvSpPr>
-            <a:spLocks xmlns:a="http://schemas.openxmlformats.org/drawingml/2006/main" noGrp="1"/>
-          </p:cNvSpPr>
-          <p:nvPr/>
-        </p:nvSpPr>
-        <p:spPr>
-          <a:xfrm xmlns:a="http://schemas.openxmlformats.org/drawingml/2006/main">
-            <a:off x="7362825" y="5600700"/>
-            <a:ext cx="7315200" cy="552450"/>
-          </a:xfrm>
-          <a:prstGeom xmlns:a="http://schemas.openxmlformats.org/drawingml/2006/main" prst="rect">
-            <a:avLst/>
-          </a:prstGeom>
-          <a:solidFill xmlns:a="http://schemas.openxmlformats.org/drawingml/2006/main">
-            <a:srgbClr val="102E38"/>
-          </a:solidFill>
-        </p:spPr>
-      </p:sp>
-      <p:sp>
-        <p:nvSpPr>
-          <p:cNvPr id="50" name="placement-number-5">
-            <a:extLst xmlns:a="http://schemas.openxmlformats.org/drawingml/2006/main">
-              <a:ext uri="{FF2B5EF4-FFF2-40B4-BE49-F238E27FC236}">
-                <a16:creationId xmlns:a16="http://schemas.microsoft.com/office/drawing/2014/main" id="{52163099-08AF-4F74-BF30-29DF39700BCD}"/>
-              </a:ext>
-            </a:extLst>
-          </p:cNvPr>
-          <p:cNvSpPr>
-            <a:spLocks xmlns:a="http://schemas.openxmlformats.org/drawingml/2006/main" noGrp="1"/>
-          </p:cNvSpPr>
-          <p:nvPr/>
-        </p:nvSpPr>
-        <p:spPr>
-          <a:xfrm xmlns:a="http://schemas.openxmlformats.org/drawingml/2006/main">
-            <a:off x="7496175" y="5715000"/>
-            <a:ext cx="266700" cy="285750"/>
-          </a:xfrm>
-          <a:prstGeom xmlns:a="http://schemas.openxmlformats.org/drawingml/2006/main" prst="rect">
-            <a:avLst/>
-          </a:prstGeom>
-        </p:spPr>
-        <p:txBody>
-          <a:bodyPr xmlns:a="http://schemas.openxmlformats.org/drawingml/2006/main" wrap="none" lIns="0" tIns="0" rIns="0" bIns="0" anchor="ctr"/>
-          <a:lstStyle xmlns:a="http://schemas.openxmlformats.org/drawingml/2006/main"/>
-          <a:p xmlns:a="http://schemas.openxmlformats.org/drawingml/2006/main">
-            <a:pPr algn="l">
-              <a:defRPr sz="1125" b="0">
-                <a:solidFill>
-                  <a:srgbClr val="D5B477"/>
-                </a:solidFill>
-                <a:latin typeface="Courier New"/>
-                <a:ea typeface="Courier New"/>
-                <a:cs typeface="Courier New"/>
-              </a:defRPr>
-            </a:pPr>
-            <a:r>
-              <a:rPr sz="1125" b="0">
-                <a:solidFill>
-                  <a:srgbClr val="D5B477"/>
-                </a:solidFill>
-                <a:latin typeface="Courier New"/>
-                <a:ea typeface="Courier New"/>
-                <a:cs typeface="Courier New"/>
-              </a:rPr>
-              <a:t>6</a:t>
-            </a:r>
-          </a:p>
-        </p:txBody>
-      </p:sp>
-      <p:sp>
-        <p:nvSpPr>
-          <p:cNvPr id="51" name="placement-name-5">
-            <a:extLst xmlns:a="http://schemas.openxmlformats.org/drawingml/2006/main">
-              <a:ext uri="{FF2B5EF4-FFF2-40B4-BE49-F238E27FC236}">
-                <a16:creationId xmlns:a16="http://schemas.microsoft.com/office/drawing/2014/main" id="{62D75C8E-0DAF-4352-99CE-C2D9365738BD}"/>
-              </a:ext>
-            </a:extLst>
-          </p:cNvPr>
-          <p:cNvSpPr>
-            <a:spLocks xmlns:a="http://schemas.openxmlformats.org/drawingml/2006/main" noGrp="1"/>
-          </p:cNvSpPr>
-          <p:nvPr/>
-        </p:nvSpPr>
-        <p:spPr>
-          <a:xfrm xmlns:a="http://schemas.openxmlformats.org/drawingml/2006/main">
-            <a:off x="7877175" y="5686425"/>
-            <a:ext cx="2667000" cy="323850"/>
-          </a:xfrm>
-          <a:prstGeom xmlns:a="http://schemas.openxmlformats.org/drawingml/2006/main" prst="rect">
-            <a:avLst/>
-          </a:prstGeom>
-        </p:spPr>
-        <p:txBody>
-          <a:bodyPr xmlns:a="http://schemas.openxmlformats.org/drawingml/2006/main" wrap="none" lIns="0" tIns="0" rIns="0" bIns="0" anchor="ctr"/>
-          <a:lstStyle xmlns:a="http://schemas.openxmlformats.org/drawingml/2006/main"/>
-          <a:p xmlns:a="http://schemas.openxmlformats.org/drawingml/2006/main">
-            <a:pPr algn="l">
-              <a:defRPr sz="1725" b="1">
-                <a:solidFill>
-                  <a:srgbClr val="F3EFDF"/>
-                </a:solidFill>
-                <a:latin typeface="Arial"/>
-                <a:ea typeface="Arial"/>
-                <a:cs typeface="Arial"/>
-              </a:defRPr>
-            </a:pPr>
-            <a:r>
-              <a:rPr sz="1725" b="1">
-                <a:solidFill>
-                  <a:srgbClr val="F3EFDF"/>
-                </a:solidFill>
-                <a:latin typeface="Arial"/>
-                <a:ea typeface="Arial"/>
-                <a:cs typeface="Arial"/>
-              </a:rPr>
-              <a:t>Large back</a:t>
-            </a:r>
-          </a:p>
-        </p:txBody>
-      </p:sp>
-      <p:sp>
-        <p:nvSpPr>
-          <p:cNvPr id="52" name="placement-slots-5">
-            <a:extLst xmlns:a="http://schemas.openxmlformats.org/drawingml/2006/main">
-              <a:ext uri="{FF2B5EF4-FFF2-40B4-BE49-F238E27FC236}">
-                <a16:creationId xmlns:a16="http://schemas.microsoft.com/office/drawing/2014/main" id="{AD12FD7F-7C5E-4BB7-8E3E-FECAD564DD61}"/>
-              </a:ext>
-            </a:extLst>
-          </p:cNvPr>
-          <p:cNvSpPr>
-            <a:spLocks xmlns:a="http://schemas.openxmlformats.org/drawingml/2006/main" noGrp="1"/>
-          </p:cNvSpPr>
-          <p:nvPr/>
-        </p:nvSpPr>
-        <p:spPr>
-          <a:xfrm xmlns:a="http://schemas.openxmlformats.org/drawingml/2006/main">
-            <a:off x="10668000" y="5686425"/>
-            <a:ext cx="685800" cy="323850"/>
-          </a:xfrm>
-          <a:prstGeom xmlns:a="http://schemas.openxmlformats.org/drawingml/2006/main" prst="rect">
-            <a:avLst/>
-          </a:prstGeom>
-        </p:spPr>
-        <p:txBody>
-          <a:bodyPr xmlns:a="http://schemas.openxmlformats.org/drawingml/2006/main" wrap="none" lIns="0" tIns="0" rIns="0" bIns="0" anchor="ctr"/>
-          <a:lstStyle xmlns:a="http://schemas.openxmlformats.org/drawingml/2006/main"/>
-          <a:p xmlns:a="http://schemas.openxmlformats.org/drawingml/2006/main">
-            <a:pPr algn="ctr">
-              <a:defRPr sz="1575" b="0">
-                <a:solidFill>
-                  <a:srgbClr val="F3EFDF"/>
-                </a:solidFill>
-                <a:latin typeface="Arial"/>
-                <a:ea typeface="Arial"/>
-                <a:cs typeface="Arial"/>
-              </a:defRPr>
-            </a:pPr>
-            <a:r>
-              <a:rPr sz="1575" b="0">
-                <a:solidFill>
-                  <a:srgbClr val="F3EFDF"/>
-                </a:solidFill>
-                <a:latin typeface="Arial"/>
-                <a:ea typeface="Arial"/>
-                <a:cs typeface="Arial"/>
-              </a:rPr>
-              <a:t>1</a:t>
-            </a:r>
-          </a:p>
-        </p:txBody>
-      </p:sp>
-      <p:sp>
-        <p:nvSpPr>
-          <p:cNvPr id="53" name="placement-price-5">
-            <a:extLst xmlns:a="http://schemas.openxmlformats.org/drawingml/2006/main">
-              <a:ext uri="{FF2B5EF4-FFF2-40B4-BE49-F238E27FC236}">
-                <a16:creationId xmlns:a16="http://schemas.microsoft.com/office/drawing/2014/main" id="{98E0FC70-8B1E-46E1-B564-72CB28AE8D1D}"/>
-              </a:ext>
-            </a:extLst>
-          </p:cNvPr>
-          <p:cNvSpPr>
-            <a:spLocks xmlns:a="http://schemas.openxmlformats.org/drawingml/2006/main" noGrp="1"/>
-          </p:cNvSpPr>
-          <p:nvPr/>
-        </p:nvSpPr>
-        <p:spPr>
-          <a:xfrm xmlns:a="http://schemas.openxmlformats.org/drawingml/2006/main">
-            <a:off x="11620500" y="5686425"/>
-            <a:ext cx="1314450" cy="323850"/>
-          </a:xfrm>
-          <a:prstGeom xmlns:a="http://schemas.openxmlformats.org/drawingml/2006/main" prst="rect">
-            <a:avLst/>
-          </a:prstGeom>
-        </p:spPr>
-        <p:txBody>
-          <a:bodyPr xmlns:a="http://schemas.openxmlformats.org/drawingml/2006/main" wrap="none" lIns="0" tIns="0" rIns="0" bIns="0" anchor="ctr"/>
-          <a:lstStyle xmlns:a="http://schemas.openxmlformats.org/drawingml/2006/main"/>
-          <a:p xmlns:a="http://schemas.openxmlformats.org/drawingml/2006/main">
-            <a:pPr algn="r">
-              <a:defRPr sz="1725" b="0">
-                <a:solidFill>
-                  <a:srgbClr val="F3EFDF"/>
-                </a:solidFill>
-                <a:latin typeface="Georgia"/>
-                <a:ea typeface="Georgia"/>
-                <a:cs typeface="Georgia"/>
-              </a:defRPr>
-            </a:pPr>
-            <a:r>
-              <a:rPr sz="1725" b="0">
-                <a:solidFill>
-                  <a:srgbClr val="F3EFDF"/>
-                </a:solidFill>
-                <a:latin typeface="Georgia"/>
-                <a:ea typeface="Georgia"/>
-                <a:cs typeface="Georgia"/>
-              </a:rPr>
-              <a:t>$21,000</a:t>
-            </a:r>
-          </a:p>
-        </p:txBody>
-      </p:sp>
-      <p:sp>
-        <p:nvSpPr>
-          <p:cNvPr id="54" name="placement-revenue-5">
-            <a:extLst xmlns:a="http://schemas.openxmlformats.org/drawingml/2006/main">
-              <a:ext uri="{FF2B5EF4-FFF2-40B4-BE49-F238E27FC236}">
-                <a16:creationId xmlns:a16="http://schemas.microsoft.com/office/drawing/2014/main" id="{51F02D85-66C3-4641-BA3A-5C01DBB01DBF}"/>
-              </a:ext>
-            </a:extLst>
-          </p:cNvPr>
-          <p:cNvSpPr>
-            <a:spLocks xmlns:a="http://schemas.openxmlformats.org/drawingml/2006/main" noGrp="1"/>
-          </p:cNvSpPr>
-          <p:nvPr/>
-        </p:nvSpPr>
-        <p:spPr>
-          <a:xfrm xmlns:a="http://schemas.openxmlformats.org/drawingml/2006/main">
-            <a:off x="13239750" y="5686425"/>
-            <a:ext cx="1419225" cy="323850"/>
-          </a:xfrm>
-          <a:prstGeom xmlns:a="http://schemas.openxmlformats.org/drawingml/2006/main" prst="rect">
-            <a:avLst/>
-          </a:prstGeom>
-        </p:spPr>
-        <p:txBody>
-          <a:bodyPr xmlns:a="http://schemas.openxmlformats.org/drawingml/2006/main" wrap="none" lIns="0" tIns="0" rIns="0" bIns="0" anchor="ctr"/>
-          <a:lstStyle xmlns:a="http://schemas.openxmlformats.org/drawingml/2006/main"/>
-          <a:p xmlns:a="http://schemas.openxmlformats.org/drawingml/2006/main">
-            <a:pPr algn="r">
-              <a:defRPr sz="1725" b="0">
-                <a:solidFill>
-                  <a:srgbClr val="F3EFDF"/>
-                </a:solidFill>
-                <a:latin typeface="Georgia"/>
-                <a:ea typeface="Georgia"/>
-                <a:cs typeface="Georgia"/>
-              </a:defRPr>
-            </a:pPr>
-            <a:r>
-              <a:rPr sz="1725" b="0">
-                <a:solidFill>
-                  <a:srgbClr val="F3EFDF"/>
-                </a:solidFill>
-                <a:latin typeface="Georgia"/>
-                <a:ea typeface="Georgia"/>
-                <a:cs typeface="Georgia"/>
-              </a:rPr>
-              <a:t>$21,000</a:t>
-            </a:r>
-          </a:p>
-        </p:txBody>
-      </p:sp>
-      <p:sp>
-        <p:nvSpPr>
-          <p:cNvPr id="55" name="total-rule">
-            <a:extLst xmlns:a="http://schemas.openxmlformats.org/drawingml/2006/main">
-              <a:ext uri="{FF2B5EF4-FFF2-40B4-BE49-F238E27FC236}">
-                <a16:creationId xmlns:a16="http://schemas.microsoft.com/office/drawing/2014/main" id="{5E281884-9135-46A1-AB4E-584D5D6A635D}"/>
-              </a:ext>
-            </a:extLst>
-          </p:cNvPr>
-          <p:cNvSpPr>
-            <a:spLocks xmlns:a="http://schemas.openxmlformats.org/drawingml/2006/main" noGrp="1"/>
-          </p:cNvSpPr>
-          <p:nvPr/>
-        </p:nvSpPr>
-        <p:spPr>
-          <a:xfrm xmlns:a="http://schemas.openxmlformats.org/drawingml/2006/main">
-            <a:off x="7477125" y="6515100"/>
-            <a:ext cx="7181850" cy="9525"/>
-          </a:xfrm>
-          <a:prstGeom xmlns:a="http://schemas.openxmlformats.org/drawingml/2006/main" prst="rect">
-            <a:avLst/>
-          </a:prstGeom>
-          <a:solidFill xmlns:a="http://schemas.openxmlformats.org/drawingml/2006/main">
-            <a:srgbClr val="B89553"/>
-          </a:solidFill>
-        </p:spPr>
-      </p:sp>
-      <p:sp>
-        <p:nvSpPr>
-          <p:cNvPr id="56" name="total-label">
-            <a:extLst xmlns:a="http://schemas.openxmlformats.org/drawingml/2006/main">
-              <a:ext uri="{FF2B5EF4-FFF2-40B4-BE49-F238E27FC236}">
-                <a16:creationId xmlns:a16="http://schemas.microsoft.com/office/drawing/2014/main" id="{9BEBBDBE-C446-4468-A763-C6F23D14AC53}"/>
-              </a:ext>
-            </a:extLst>
-          </p:cNvPr>
-          <p:cNvSpPr>
-            <a:spLocks xmlns:a="http://schemas.openxmlformats.org/drawingml/2006/main" noGrp="1"/>
-          </p:cNvSpPr>
-          <p:nvPr/>
-        </p:nvSpPr>
-        <p:spPr>
-          <a:xfrm xmlns:a="http://schemas.openxmlformats.org/drawingml/2006/main">
-            <a:off x="7477125" y="6724650"/>
-            <a:ext cx="3810000" cy="257175"/>
-          </a:xfrm>
-          <a:prstGeom xmlns:a="http://schemas.openxmlformats.org/drawingml/2006/main" prst="rect">
-            <a:avLst/>
-          </a:prstGeom>
-        </p:spPr>
-        <p:txBody>
-          <a:bodyPr xmlns:a="http://schemas.openxmlformats.org/drawingml/2006/main" wrap="none" lIns="0" tIns="0" rIns="0" bIns="0" anchor="ctr"/>
-          <a:lstStyle xmlns:a="http://schemas.openxmlformats.org/drawingml/2006/main"/>
-          <a:p xmlns:a="http://schemas.openxmlformats.org/drawingml/2006/main">
-            <a:pPr algn="l">
-              <a:defRPr sz="975" b="0">
-                <a:solidFill>
-                  <a:srgbClr val="56686A"/>
-                </a:solidFill>
-                <a:latin typeface="Courier New"/>
-                <a:ea typeface="Courier New"/>
-                <a:cs typeface="Courier New"/>
-              </a:defRPr>
-            </a:pPr>
-            <a:r>
-              <a:rPr sz="975" b="0">
-                <a:solidFill>
-                  <a:srgbClr val="56686A"/>
-                </a:solidFill>
-                <a:latin typeface="Courier New"/>
-                <a:ea typeface="Courier New"/>
-                <a:cs typeface="Courier New"/>
-              </a:rPr>
-              <a:t>TOTAL SPONSORSHIP INVENTORY</a:t>
-            </a:r>
-          </a:p>
-        </p:txBody>
-      </p:sp>
-      <p:sp>
-        <p:nvSpPr>
-          <p:cNvPr id="57" name="total-slots">
-            <a:extLst xmlns:a="http://schemas.openxmlformats.org/drawingml/2006/main">
-              <a:ext uri="{FF2B5EF4-FFF2-40B4-BE49-F238E27FC236}">
-                <a16:creationId xmlns:a16="http://schemas.microsoft.com/office/drawing/2014/main" id="{71C0DA3A-8A18-4B31-A8C6-BDF20E5D8156}"/>
-              </a:ext>
-            </a:extLst>
-          </p:cNvPr>
-          <p:cNvSpPr>
-            <a:spLocks xmlns:a="http://schemas.openxmlformats.org/drawingml/2006/main" noGrp="1"/>
-          </p:cNvSpPr>
-          <p:nvPr/>
-        </p:nvSpPr>
-        <p:spPr>
-          <a:xfrm xmlns:a="http://schemas.openxmlformats.org/drawingml/2006/main">
-            <a:off x="7477125" y="7077075"/>
-            <a:ext cx="4095750" cy="266700"/>
-          </a:xfrm>
-          <a:prstGeom xmlns:a="http://schemas.openxmlformats.org/drawingml/2006/main" prst="rect">
-            <a:avLst/>
-          </a:prstGeom>
-        </p:spPr>
-        <p:txBody>
-          <a:bodyPr xmlns:a="http://schemas.openxmlformats.org/drawingml/2006/main" wrap="none" lIns="0" tIns="0" rIns="0" bIns="0" anchor="ctr"/>
-          <a:lstStyle xmlns:a="http://schemas.openxmlformats.org/drawingml/2006/main"/>
-          <a:p xmlns:a="http://schemas.openxmlformats.org/drawingml/2006/main">
-            <a:pPr algn="l">
-              <a:defRPr sz="1500" b="0">
-                <a:solidFill>
-                  <a:srgbClr val="102E38"/>
-                </a:solidFill>
-                <a:latin typeface="Arial"/>
-                <a:ea typeface="Arial"/>
-                <a:cs typeface="Arial"/>
-              </a:defRPr>
-            </a:pPr>
-            <a:r>
-              <a:rPr sz="1500" b="0">
-                <a:solidFill>
-                  <a:srgbClr val="102E38"/>
-                </a:solidFill>
-                <a:latin typeface="Arial"/>
-                <a:ea typeface="Arial"/>
-                <a:cs typeface="Arial"/>
-              </a:rPr>
-              <a:t>10 placements across ~30 parkas</a:t>
-            </a:r>
-          </a:p>
-        </p:txBody>
-      </p:sp>
-      <p:sp>
-        <p:nvSpPr>
-          <p:cNvPr id="58" name="total-revenue">
-            <a:extLst xmlns:a="http://schemas.openxmlformats.org/drawingml/2006/main">
-              <a:ext uri="{FF2B5EF4-FFF2-40B4-BE49-F238E27FC236}">
-                <a16:creationId xmlns:a16="http://schemas.microsoft.com/office/drawing/2014/main" id="{F55E6FB7-AC9A-4836-A7D7-3BE23A978F25}"/>
-              </a:ext>
-            </a:extLst>
-          </p:cNvPr>
-          <p:cNvSpPr>
-            <a:spLocks xmlns:a="http://schemas.openxmlformats.org/drawingml/2006/main" noGrp="1"/>
-          </p:cNvSpPr>
-          <p:nvPr/>
-        </p:nvSpPr>
-        <p:spPr>
-          <a:xfrm xmlns:a="http://schemas.openxmlformats.org/drawingml/2006/main">
-            <a:off x="11591925" y="6677025"/>
-            <a:ext cx="3067050" cy="800100"/>
-          </a:xfrm>
-          <a:prstGeom xmlns:a="http://schemas.openxmlformats.org/drawingml/2006/main" prst="rect">
-            <a:avLst/>
-          </a:prstGeom>
-        </p:spPr>
-        <p:txBody>
-          <a:bodyPr xmlns:a="http://schemas.openxmlformats.org/drawingml/2006/main" wrap="none" lIns="0" tIns="0" rIns="0" bIns="0" anchor="ctr"/>
-          <a:lstStyle xmlns:a="http://schemas.openxmlformats.org/drawingml/2006/main"/>
-          <a:p xmlns:a="http://schemas.openxmlformats.org/drawingml/2006/main">
-            <a:pPr algn="r">
-              <a:defRPr sz="4725" b="0">
-                <a:solidFill>
-                  <a:srgbClr val="102E38"/>
-                </a:solidFill>
-                <a:latin typeface="Georgia"/>
-                <a:ea typeface="Georgia"/>
-                <a:cs typeface="Georgia"/>
-              </a:defRPr>
-            </a:pPr>
-            <a:r>
-              <a:rPr sz="4725" b="0">
-                <a:solidFill>
-                  <a:srgbClr val="102E38"/>
-                </a:solidFill>
-                <a:latin typeface="Georgia"/>
-                <a:ea typeface="Georgia"/>
-                <a:cs typeface="Georgia"/>
-              </a:rPr>
-              <a:t>$59,000</a:t>
-            </a:r>
-          </a:p>
-        </p:txBody>
-      </p:sp>
-      <p:sp>
-        <p:nvSpPr>
-          <p:cNvPr id="59" name="terms">
-            <a:extLst xmlns:a="http://schemas.openxmlformats.org/drawingml/2006/main">
-              <a:ext uri="{FF2B5EF4-FFF2-40B4-BE49-F238E27FC236}">
-                <a16:creationId xmlns:a16="http://schemas.microsoft.com/office/drawing/2014/main" id="{76968606-EB12-40C1-99BC-C774E53E1E4D}"/>
-              </a:ext>
-            </a:extLst>
-          </p:cNvPr>
-          <p:cNvSpPr>
-            <a:spLocks xmlns:a="http://schemas.openxmlformats.org/drawingml/2006/main" noGrp="1"/>
-          </p:cNvSpPr>
-          <p:nvPr/>
-        </p:nvSpPr>
-        <p:spPr>
-          <a:xfrm xmlns:a="http://schemas.openxmlformats.org/drawingml/2006/main">
-            <a:off x="7477125" y="7762875"/>
-            <a:ext cx="7181850" cy="238125"/>
-          </a:xfrm>
-          <a:prstGeom xmlns:a="http://schemas.openxmlformats.org/drawingml/2006/main" prst="rect">
-            <a:avLst/>
-          </a:prstGeom>
-        </p:spPr>
-        <p:txBody>
-          <a:bodyPr xmlns:a="http://schemas.openxmlformats.org/drawingml/2006/main" wrap="none" lIns="0" tIns="0" rIns="0" bIns="0" anchor="ctr"/>
-          <a:lstStyle xmlns:a="http://schemas.openxmlformats.org/drawingml/2006/main"/>
-          <a:p xmlns:a="http://schemas.openxmlformats.org/drawingml/2006/main">
-            <a:pPr algn="l">
-              <a:defRPr sz="1200" b="0">
-                <a:solidFill>
-                  <a:srgbClr val="56686A"/>
-                </a:solidFill>
-                <a:latin typeface="Arial"/>
-                <a:ea typeface="Arial"/>
-                <a:cs typeface="Arial"/>
-              </a:defRPr>
-            </a:pPr>
-            <a:r>
-              <a:rPr sz="1200" b="0">
-                <a:solidFill>
-                  <a:srgbClr val="56686A"/>
-                </a:solidFill>
-                <a:latin typeface="Arial"/>
-                <a:ea typeface="Arial"/>
-                <a:cs typeface="Arial"/>
-              </a:rPr>
-              <a:t>Each price covers all parkas. Expedition tickets are separate.</a:t>
-            </a:r>
-          </a:p>
-        </p:txBody>
-      </p:sp>
-      <p:sp>
-        <p:nvSpPr>
-          <p:cNvPr id="60" name="terms-second">
-            <a:extLst xmlns:a="http://schemas.openxmlformats.org/drawingml/2006/main">
-              <a:ext uri="{FF2B5EF4-FFF2-40B4-BE49-F238E27FC236}">
-                <a16:creationId xmlns:a16="http://schemas.microsoft.com/office/drawing/2014/main" id="{E6F16F5F-0AC2-4955-8473-869570175677}"/>
-              </a:ext>
-            </a:extLst>
-          </p:cNvPr>
-          <p:cNvSpPr>
-            <a:spLocks xmlns:a="http://schemas.openxmlformats.org/drawingml/2006/main" noGrp="1"/>
-          </p:cNvSpPr>
-          <p:nvPr/>
-        </p:nvSpPr>
-        <p:spPr>
-          <a:xfrm xmlns:a="http://schemas.openxmlformats.org/drawingml/2006/main">
-            <a:off x="7477125" y="8029575"/>
-            <a:ext cx="7181850" cy="238125"/>
-          </a:xfrm>
-          <a:prstGeom xmlns:a="http://schemas.openxmlformats.org/drawingml/2006/main" prst="rect">
-            <a:avLst/>
-          </a:prstGeom>
-        </p:spPr>
-        <p:txBody>
-          <a:bodyPr xmlns:a="http://schemas.openxmlformats.org/drawingml/2006/main" wrap="none" lIns="0" tIns="0" rIns="0" bIns="0" anchor="ctr"/>
-          <a:lstStyle xmlns:a="http://schemas.openxmlformats.org/drawingml/2006/main"/>
-          <a:p xmlns:a="http://schemas.openxmlformats.org/drawingml/2006/main">
-            <a:pPr algn="l">
+              <a:buNone/>
               <a:defRPr sz="1200" b="0">
                 <a:solidFill>
                   <a:srgbClr val="56686A"/>

</xml_diff>